<commit_message>
Retirer la diapositive de déploiement, ajouter le planning août-septembre
La présentation passe à 17 diapositives et n'affiche plus d'adresse de site.
Nouveau PDF : répartition du travail du 1er août au 25 septembre, semaine
par semaine (apprentissage puis réalisation du projet).

Co-Authored-By: Claude Opus 5.5 <noreply@anthropic.com>
Claude-Session: https://claude.ai/code/session_01PQ7mGnziojE1DidZix39sr
</commit_message>
<xml_diff>
--- a/livrables/Patrimo_soutenance.pptx
+++ b/livrables/Patrimo_soutenance.pptx
@@ -22,10 +22,9 @@
     <p:sldId id="270" r:id="rId16"/>
     <p:sldId id="271" r:id="rId17"/>
     <p:sldId id="272" r:id="rId18"/>
-    <p:sldId id="273" r:id="rId19"/>
   </p:sldIdLst>
   <p:notesMasterIdLst>
-    <p:notesMasterId r:id="rId20"/>
+    <p:notesMasterId r:id="rId19"/>
   </p:notesMasterIdLst>
   <p:sldSz cx="12192000" cy="6858000"/>
   <p:notesSz cx="6858000" cy="12192000"/>
@@ -1058,9 +1057,11 @@
           <a:p>
             <a:r>
               <a:rPr lang="en-US" dirty="0"/>
-              <a:t>Pour la mise en ligne, j'ai choisi InfinityFree : c'est gratuit et ça fournit exactement Apache, PHP et MySQL.
-Le déploiement se fait en cinq étapes : créer la base dans le panneau, importer le fichier SQL dans phpMyAdmin, mettre les identifiants dans config.php, envoyer les fichiers dans htdocs, puis activer le certificat SSL.
-Trois adaptations ont été nécessaires pour cet hébergeur : les dates en français sont faites à la main parce que l'extension intl n'est pas toujours disponible, les polices sont hébergées avec le site, et le .htaccess fonctionne avec les deux versions d'Apache. Pour travailler en local, un fichier config.local.php prend le dessus sur la configuration de production.</a:t>
+              <a:t>Je voulais aussi parler des difficultés, parce que c'est là que j'ai le plus appris.
+Un : en concevant les formulaires, j'ai vu que si l'état et la direction étaient modifiables dans le formulaire de modification, on pourrait contourner l'historique. Ces champs n'y sont donc pas : on ne peut les changer que par une action qui écrit dans l'historique.
+Deux : que se passe-t-il si un matériel est réformé pendant qu'un transfert est en attente ? J'ai ajouté une vérification au moment de la dernière validation, qui annule la demande.
+Trois : mes requêtes de comptage marchaient chez moi mais pas avec MySQL en mode strict, à cause du GROUP BY. J'ai corrigé en listant toutes les colonnes.
+Quatre : la génération du fichier CSV en PHP 8.4 affichait des avertissements dans le fichier ; il fallait préciser un paramètre de fputcsv.</a:t>
             </a:r>
             <a:endParaRPr lang="en-US" dirty="0"/>
           </a:p>
@@ -1148,11 +1149,9 @@
           <a:p>
             <a:r>
               <a:rPr lang="en-US" dirty="0"/>
-              <a:t>Je voulais aussi parler des difficultés, parce que c'est là que j'ai le plus appris.
-Un : en concevant les formulaires, j'ai vu que si l'état et la direction étaient modifiables dans le formulaire de modification, on pourrait contourner l'historique. Ces champs n'y sont donc pas : on ne peut les changer que par une action qui écrit dans l'historique.
-Deux : que se passe-t-il si un matériel est réformé pendant qu'un transfert est en attente ? J'ai ajouté une vérification au moment de la dernière validation, qui annule la demande.
-Trois : mes requêtes de comptage marchaient chez moi mais pas avec MySQL en mode strict, à cause du GROUP BY. J'ai corrigé en listant toutes les colonnes.
-Quatre : la génération du fichier CSV en PHP 8.4 affichait des avertissements dans le fichier ; il fallait préciser un paramètre de fputcsv.</a:t>
+              <a:t>En bilan : ce projet m'a appris à partir d'un besoin réel, à le traduire en base de données, puis en écrans.
+J'ai surtout compris l'importance des contraintes : les clés étrangères et les transactions protègent les données mieux que n'importe quel contrôle dans l'interface. Et j'ai appris à mettre une application en ligne.
+Pour la suite, plusieurs pistes : scanner le code-barres avec la caméra du téléphone pendant l'inventaire, joindre le PV de réforme en PDF, prévenir les responsables par e-mail quand un transfert les attend, et calculer l'amortissement pour la comptabilité.</a:t>
             </a:r>
             <a:endParaRPr lang="en-US" dirty="0"/>
           </a:p>
@@ -1240,9 +1239,7 @@
           <a:p>
             <a:r>
               <a:rPr lang="en-US" dirty="0"/>
-              <a:t>En bilan : ce projet m'a appris à partir d'un besoin réel, à le traduire en base de données, puis en écrans.
-J'ai surtout compris l'importance des contraintes : les clés étrangères et les transactions protègent les données mieux que n'importe quel contrôle dans l'interface. Et j'ai appris à mettre une application en ligne.
-Pour la suite, plusieurs pistes : scanner le code-barres avec la caméra du téléphone pendant l'inventaire, joindre le PV de réforme en PDF, prévenir les responsables par e-mail quand un transfert les attend, et calculer l'amortissement pour la comptabilité.</a:t>
+              <a:t>Merci de m'avoir écouté. Je vais maintenant faire une courte démonstration en direct : je me connecte comme responsable du patrimoine, j'enregistre un matériel, je change son état, puis je me connecte comme responsable de la DAF pour valider un transfert. Ensuite je réponds à vos questions.</a:t>
             </a:r>
             <a:endParaRPr lang="en-US" dirty="0"/>
           </a:p>
@@ -1266,94 +1263,6 @@
             <a:fld id="{F7021451-1387-4CA6-816F-3879F97B5CBC}" type="slidenum">
               <a:rPr lang="en-US"/>
               <a:t>17</a:t>
-            </a:fld>
-            <a:endParaRPr lang="en-US"/>
-          </a:p>
-        </p:txBody>
-      </p:sp>
-    </p:spTree>
-    <p:extLst>
-      <p:ext uri="{BB962C8B-B14F-4D97-AF65-F5344CB8AC3E}">
-        <p14:creationId xmlns:p14="http://schemas.microsoft.com/office/powerpoint/2010/main" val="1024086991"/>
-      </p:ext>
-    </p:extLst>
-  </p:cSld>
-  <p:clrMapOvr>
-    <a:masterClrMapping/>
-  </p:clrMapOvr>
-</p:notes>
-</file>
-
-<file path=ppt/notesSlides/notesSlide18.xml><?xml version="1.0" encoding="utf-8"?>
-<p:notes xmlns:a="http://schemas.openxmlformats.org/drawingml/2006/main" xmlns:r="http://schemas.openxmlformats.org/officeDocument/2006/relationships" xmlns:p="http://schemas.openxmlformats.org/presentationml/2006/main">
-  <p:cSld>
-    <p:spTree>
-      <p:nvGrpSpPr>
-        <p:cNvPr id="1" name=""/>
-        <p:cNvGrpSpPr/>
-        <p:nvPr/>
-      </p:nvGrpSpPr>
-      <p:grpSpPr>
-        <a:xfrm>
-          <a:off x="0" y="0"/>
-          <a:ext cx="0" cy="0"/>
-          <a:chOff x="0" y="0"/>
-          <a:chExt cx="0" cy="0"/>
-        </a:xfrm>
-      </p:grpSpPr>
-      <p:sp>
-        <p:nvSpPr>
-          <p:cNvPr id="2" name="Slide Image Placeholder 1"/>
-          <p:cNvSpPr>
-            <a:spLocks noGrp="1" noRot="1" noChangeAspect="1"/>
-          </p:cNvSpPr>
-          <p:nvPr>
-            <p:ph type="sldImg"/>
-          </p:nvPr>
-        </p:nvSpPr>
-        <p:spPr/>
-      </p:sp>
-      <p:sp>
-        <p:nvSpPr>
-          <p:cNvPr id="3" name="Notes Placeholder 2"/>
-          <p:cNvSpPr>
-            <a:spLocks noGrp="1"/>
-          </p:cNvSpPr>
-          <p:nvPr>
-            <p:ph type="body" idx="1"/>
-          </p:nvPr>
-        </p:nvSpPr>
-        <p:spPr/>
-        <p:txBody>
-          <a:bodyPr/>
-          <a:lstStyle/>
-          <a:p>
-            <a:r>
-              <a:rPr lang="en-US" dirty="0"/>
-              <a:t>Merci de m'avoir écouté. Je vais maintenant faire une courte démonstration en direct : je me connecte comme responsable du patrimoine, j'enregistre un matériel, je change son état, puis je me connecte comme responsable de la DAF pour valider un transfert. Ensuite je réponds à vos questions.</a:t>
-            </a:r>
-            <a:endParaRPr lang="en-US" dirty="0"/>
-          </a:p>
-        </p:txBody>
-      </p:sp>
-      <p:sp>
-        <p:nvSpPr>
-          <p:cNvPr id="4" name="Slide Number Placeholder 3"/>
-          <p:cNvSpPr>
-            <a:spLocks noGrp="1"/>
-          </p:cNvSpPr>
-          <p:nvPr>
-            <p:ph type="sldNum" sz="quarter" idx="10"/>
-          </p:nvPr>
-        </p:nvSpPr>
-        <p:spPr/>
-        <p:txBody>
-          <a:bodyPr/>
-          <a:lstStyle/>
-          <a:p>
-            <a:fld id="{F7021451-1387-4CA6-816F-3879F97B5CBC}" type="slidenum">
-              <a:rPr lang="en-US"/>
-              <a:t>18</a:t>
             </a:fld>
             <a:endParaRPr lang="en-US"/>
           </a:p>
@@ -3427,7 +3336,7 @@
                 <a:ea typeface="Consolas" pitchFamily="34" charset="-122"/>
                 <a:cs typeface="Consolas" pitchFamily="34" charset="-120"/>
               </a:rPr>
-              <a:t>10 / 18</a:t>
+              <a:t>10 / 17</a:t>
             </a:r>
             <a:endParaRPr lang="en-US" sz="900" dirty="0"/>
           </a:p>
@@ -4052,7 +3961,7 @@
                 <a:ea typeface="Consolas" pitchFamily="34" charset="-122"/>
                 <a:cs typeface="Consolas" pitchFamily="34" charset="-120"/>
               </a:rPr>
-              <a:t>11 / 18</a:t>
+              <a:t>11 / 17</a:t>
             </a:r>
             <a:endParaRPr lang="en-US" sz="900" dirty="0"/>
           </a:p>
@@ -4560,7 +4469,7 @@
                 <a:ea typeface="Consolas" pitchFamily="34" charset="-122"/>
                 <a:cs typeface="Consolas" pitchFamily="34" charset="-120"/>
               </a:rPr>
-              <a:t>12 / 18</a:t>
+              <a:t>12 / 17</a:t>
             </a:r>
             <a:endParaRPr lang="en-US" sz="900" dirty="0"/>
           </a:p>
@@ -5226,7 +5135,7 @@
                 <a:ea typeface="Consolas" pitchFamily="34" charset="-122"/>
                 <a:cs typeface="Consolas" pitchFamily="34" charset="-120"/>
               </a:rPr>
-              <a:t>13 / 18</a:t>
+              <a:t>13 / 17</a:t>
             </a:r>
             <a:endParaRPr lang="en-US" sz="900" dirty="0"/>
           </a:p>
@@ -6332,7 +6241,7 @@
                 <a:ea typeface="Consolas" pitchFamily="34" charset="-122"/>
                 <a:cs typeface="Consolas" pitchFamily="34" charset="-120"/>
               </a:rPr>
-              <a:t>14 / 18</a:t>
+              <a:t>14 / 17</a:t>
             </a:r>
             <a:endParaRPr lang="en-US" sz="900" dirty="0"/>
           </a:p>
@@ -7696,7 +7605,7 @@
         <p:spPr>
           <a:xfrm>
             <a:off x="548640" y="384048"/>
-            <a:ext cx="1847088" cy="274320"/>
+            <a:ext cx="2578608" cy="274320"/>
           </a:xfrm>
           <a:prstGeom prst="roundRect">
             <a:avLst>
@@ -7748,7 +7657,7 @@
         <p:spPr>
           <a:xfrm>
             <a:off x="768096" y="384048"/>
-            <a:ext cx="1609344" cy="274320"/>
+            <a:ext cx="2340864" cy="274320"/>
           </a:xfrm>
           <a:prstGeom prst="rect">
             <a:avLst/>
@@ -7772,7 +7681,7 @@
                 <a:ea typeface="Consolas" pitchFamily="34" charset="-122"/>
                 <a:cs typeface="Consolas" pitchFamily="34" charset="-120"/>
               </a:rPr>
-              <a:t>12 · DÉPLOIEMENT</a:t>
+              <a:t>12 · RETOUR D'EXPÉRIENCE</a:t>
             </a:r>
             <a:endParaRPr lang="en-US" sz="1000" dirty="0"/>
           </a:p>
@@ -7811,7 +7720,7 @@
                 <a:ea typeface="Georgia" pitchFamily="34" charset="-122"/>
                 <a:cs typeface="Georgia" pitchFamily="34" charset="-120"/>
               </a:rPr>
-              <a:t>En ligne sur InfinityFree</a:t>
+              <a:t>Les difficultés, et ce que j'en ai fait</a:t>
             </a:r>
             <a:endParaRPr lang="en-US" sz="3200" dirty="0"/>
           </a:p>
@@ -7850,7 +7759,7 @@
                 <a:ea typeface="Consolas" pitchFamily="34" charset="-122"/>
                 <a:cs typeface="Consolas" pitchFamily="34" charset="-120"/>
               </a:rPr>
-              <a:t>15 / 18</a:t>
+              <a:t>15 / 17</a:t>
             </a:r>
             <a:endParaRPr lang="en-US" sz="900" dirty="0"/>
           </a:p>
@@ -7897,14 +7806,92 @@
       </p:sp>
       <p:sp>
         <p:nvSpPr>
-          <p:cNvPr id="9" name="Shape 6"/>
+          <p:cNvPr id="9" name="Text 6"/>
+          <p:cNvSpPr txBox="1"/>
+          <p:nvPr/>
+        </p:nvSpPr>
+        <p:spPr>
+          <a:xfrm>
+            <a:off x="548640" y="1664208"/>
+            <a:ext cx="3657600" cy="228600"/>
+          </a:xfrm>
+          <a:prstGeom prst="rect">
+            <a:avLst/>
+          </a:prstGeom>
+          <a:noFill/>
+          <a:ln/>
+        </p:spPr>
+        <p:txBody>
+          <a:bodyPr wrap="square" lIns="0" tIns="0" rIns="0" bIns="0" rtlCol="0" anchor="t"/>
+          <a:lstStyle/>
+          <a:p>
+            <a:pPr indent="0" marL="0">
+              <a:buNone/>
+            </a:pPr>
+            <a:r>
+              <a:rPr lang="en-US" sz="1000" b="1" spc="200" kern="0" dirty="0">
+                <a:solidFill>
+                  <a:srgbClr val="B23A2A"/>
+                </a:solidFill>
+                <a:latin typeface="Consolas" pitchFamily="34" charset="0"/>
+                <a:ea typeface="Consolas" pitchFamily="34" charset="-122"/>
+                <a:cs typeface="Consolas" pitchFamily="34" charset="-120"/>
+              </a:rPr>
+              <a:t>PROBLÈME</a:t>
+            </a:r>
+            <a:endParaRPr lang="en-US" sz="1000" dirty="0"/>
+          </a:p>
+        </p:txBody>
+      </p:sp>
+      <p:sp>
+        <p:nvSpPr>
+          <p:cNvPr id="10" name="Text 7"/>
+          <p:cNvSpPr txBox="1"/>
+          <p:nvPr/>
+        </p:nvSpPr>
+        <p:spPr>
+          <a:xfrm>
+            <a:off x="5074920" y="1664208"/>
+            <a:ext cx="3657600" cy="228600"/>
+          </a:xfrm>
+          <a:prstGeom prst="rect">
+            <a:avLst/>
+          </a:prstGeom>
+          <a:noFill/>
+          <a:ln/>
+        </p:spPr>
+        <p:txBody>
+          <a:bodyPr wrap="square" lIns="0" tIns="0" rIns="0" bIns="0" rtlCol="0" anchor="t"/>
+          <a:lstStyle/>
+          <a:p>
+            <a:pPr indent="0" marL="0">
+              <a:buNone/>
+            </a:pPr>
+            <a:r>
+              <a:rPr lang="en-US" sz="1000" b="1" spc="200" kern="0" dirty="0">
+                <a:solidFill>
+                  <a:srgbClr val="2E7250"/>
+                </a:solidFill>
+                <a:latin typeface="Consolas" pitchFamily="34" charset="0"/>
+                <a:ea typeface="Consolas" pitchFamily="34" charset="-122"/>
+                <a:cs typeface="Consolas" pitchFamily="34" charset="-120"/>
+              </a:rPr>
+              <a:t>SOLUTION</a:t>
+            </a:r>
+            <a:endParaRPr lang="en-US" sz="1000" dirty="0"/>
+          </a:p>
+        </p:txBody>
+      </p:sp>
+      <p:sp>
+        <p:nvSpPr>
+          <p:cNvPr id="11" name="Shape 8"/>
           <p:cNvSpPr/>
           <p:nvPr/>
         </p:nvSpPr>
         <p:spPr>
           <a:xfrm>
-            <a:off x="548640" y="1783080"/>
-            <a:ext cx="2103120" cy="2011680"/>
+            <a:off x="548640" y="2011680"/>
+            <a:ext cx="11094415" cy="822960"/>
           </a:xfrm>
           <a:prstGeom prst="rect">
             <a:avLst/>
@@ -7929,108 +7916,108 @@
       </p:sp>
       <p:sp>
         <p:nvSpPr>
-          <p:cNvPr id="10" name="Text 7"/>
-          <p:cNvSpPr txBox="1"/>
-          <p:nvPr/>
-        </p:nvSpPr>
-        <p:spPr>
-          <a:xfrm>
-            <a:off x="749808" y="1984248"/>
-            <a:ext cx="914400" cy="365760"/>
-          </a:xfrm>
-          <a:prstGeom prst="rect">
-            <a:avLst/>
-          </a:prstGeom>
-          <a:noFill/>
-          <a:ln/>
-        </p:spPr>
-        <p:txBody>
-          <a:bodyPr wrap="square" lIns="0" tIns="0" rIns="0" bIns="0" rtlCol="0" anchor="t"/>
-          <a:lstStyle/>
-          <a:p>
-            <a:pPr indent="0" marL="0">
-              <a:buNone/>
-            </a:pPr>
-            <a:r>
-              <a:rPr lang="en-US" sz="2600" dirty="0">
-                <a:solidFill>
-                  <a:srgbClr val="1F4A3A"/>
+          <p:cNvPr id="12" name="Text 9"/>
+          <p:cNvSpPr txBox="1"/>
+          <p:nvPr/>
+        </p:nvSpPr>
+        <p:spPr>
+          <a:xfrm>
+            <a:off x="822960" y="2011680"/>
+            <a:ext cx="3931920" cy="822960"/>
+          </a:xfrm>
+          <a:prstGeom prst="rect">
+            <a:avLst/>
+          </a:prstGeom>
+          <a:noFill/>
+          <a:ln/>
+        </p:spPr>
+        <p:txBody>
+          <a:bodyPr wrap="square" lIns="0" tIns="0" rIns="0" bIns="0" rtlCol="0" anchor="ctr"/>
+          <a:lstStyle/>
+          <a:p>
+            <a:pPr indent="0" marL="0">
+              <a:buNone/>
+            </a:pPr>
+            <a:r>
+              <a:rPr lang="en-US" sz="1550" dirty="0">
+                <a:solidFill>
+                  <a:srgbClr val="17211C"/>
                 </a:solidFill>
                 <a:latin typeface="Georgia" pitchFamily="34" charset="0"/>
                 <a:ea typeface="Georgia" pitchFamily="34" charset="-122"/>
                 <a:cs typeface="Georgia" pitchFamily="34" charset="-120"/>
               </a:rPr>
-              <a:t>01</a:t>
-            </a:r>
-            <a:endParaRPr lang="en-US" sz="2600" dirty="0"/>
-          </a:p>
-        </p:txBody>
-      </p:sp>
-      <p:sp>
-        <p:nvSpPr>
-          <p:cNvPr id="11" name="Text 8"/>
-          <p:cNvSpPr txBox="1"/>
-          <p:nvPr/>
-        </p:nvSpPr>
-        <p:spPr>
-          <a:xfrm>
-            <a:off x="749808" y="2496312"/>
-            <a:ext cx="1737360" cy="320040"/>
-          </a:xfrm>
-          <a:prstGeom prst="rect">
-            <a:avLst/>
-          </a:prstGeom>
-          <a:noFill/>
-          <a:ln/>
-        </p:spPr>
-        <p:txBody>
-          <a:bodyPr wrap="square" lIns="0" tIns="0" rIns="0" bIns="0" rtlCol="0" anchor="t"/>
-          <a:lstStyle/>
-          <a:p>
-            <a:pPr indent="0" marL="0">
-              <a:buNone/>
-            </a:pPr>
-            <a:r>
-              <a:rPr lang="en-US" sz="1500" b="1" dirty="0">
-                <a:solidFill>
-                  <a:srgbClr val="17211C"/>
+              <a:t>Risque : contourner l'historique</a:t>
+            </a:r>
+            <a:endParaRPr lang="en-US" sz="1550" dirty="0"/>
+          </a:p>
+        </p:txBody>
+      </p:sp>
+      <p:sp>
+        <p:nvSpPr>
+          <p:cNvPr id="13" name="Text 10"/>
+          <p:cNvSpPr txBox="1"/>
+          <p:nvPr/>
+        </p:nvSpPr>
+        <p:spPr>
+          <a:xfrm>
+            <a:off x="4526280" y="2011680"/>
+            <a:ext cx="365760" cy="822960"/>
+          </a:xfrm>
+          <a:prstGeom prst="rect">
+            <a:avLst/>
+          </a:prstGeom>
+          <a:noFill/>
+          <a:ln/>
+        </p:spPr>
+        <p:txBody>
+          <a:bodyPr wrap="square" lIns="0" tIns="0" rIns="0" bIns="0" rtlCol="0" anchor="ctr"/>
+          <a:lstStyle/>
+          <a:p>
+            <a:pPr algn="ctr" indent="0" marL="0">
+              <a:buNone/>
+            </a:pPr>
+            <a:r>
+              <a:rPr lang="en-US" sz="1800" dirty="0">
+                <a:solidFill>
+                  <a:srgbClr val="767A71"/>
                 </a:solidFill>
                 <a:latin typeface="Calibri" pitchFamily="34" charset="0"/>
                 <a:ea typeface="Calibri" pitchFamily="34" charset="-122"/>
                 <a:cs typeface="Calibri" pitchFamily="34" charset="-120"/>
               </a:rPr>
-              <a:t>Créer la base</a:t>
-            </a:r>
-            <a:endParaRPr lang="en-US" sz="1500" dirty="0"/>
-          </a:p>
-        </p:txBody>
-      </p:sp>
-      <p:sp>
-        <p:nvSpPr>
-          <p:cNvPr id="12" name="Text 9"/>
-          <p:cNvSpPr txBox="1"/>
-          <p:nvPr/>
-        </p:nvSpPr>
-        <p:spPr>
-          <a:xfrm>
-            <a:off x="749808" y="2834640"/>
-            <a:ext cx="1737360" cy="868680"/>
-          </a:xfrm>
-          <a:prstGeom prst="rect">
-            <a:avLst/>
-          </a:prstGeom>
-          <a:noFill/>
-          <a:ln/>
-        </p:spPr>
-        <p:txBody>
-          <a:bodyPr wrap="square" lIns="0" tIns="0" rIns="0" bIns="0" rtlCol="0" anchor="t"/>
-          <a:lstStyle/>
-          <a:p>
-            <a:pPr indent="0" marL="0">
-              <a:buNone/>
-            </a:pPr>
-            <a:r>
-              <a:rPr lang="en-US" sz="1150" dirty="0">
+              <a:t>→</a:t>
+            </a:r>
+            <a:endParaRPr lang="en-US" sz="1800" dirty="0"/>
+          </a:p>
+        </p:txBody>
+      </p:sp>
+      <p:sp>
+        <p:nvSpPr>
+          <p:cNvPr id="14" name="Text 11"/>
+          <p:cNvSpPr txBox="1"/>
+          <p:nvPr/>
+        </p:nvSpPr>
+        <p:spPr>
+          <a:xfrm>
+            <a:off x="5074920" y="2011680"/>
+            <a:ext cx="6400800" cy="822960"/>
+          </a:xfrm>
+          <a:prstGeom prst="rect">
+            <a:avLst/>
+          </a:prstGeom>
+          <a:noFill/>
+          <a:ln/>
+        </p:spPr>
+        <p:txBody>
+          <a:bodyPr wrap="square" lIns="0" tIns="0" rIns="0" bIns="0" rtlCol="0" anchor="ctr"/>
+          <a:lstStyle/>
+          <a:p>
+            <a:pPr indent="0" marL="0">
+              <a:buNone/>
+            </a:pPr>
+            <a:r>
+              <a:rPr lang="en-US" sz="1250" dirty="0">
                 <a:solidFill>
                   <a:srgbClr val="3F4842"/>
                 </a:solidFill>
@@ -8038,22 +8025,22 @@
                 <a:ea typeface="Calibri" pitchFamily="34" charset="-122"/>
                 <a:cs typeface="Calibri" pitchFamily="34" charset="-120"/>
               </a:rPr>
-              <a:t>Panneau → MySQL Databases</a:t>
-            </a:r>
-            <a:endParaRPr lang="en-US" sz="1150" dirty="0"/>
-          </a:p>
-        </p:txBody>
-      </p:sp>
-      <p:sp>
-        <p:nvSpPr>
-          <p:cNvPr id="13" name="Shape 10"/>
+              <a:t>L'état et la direction ne sont pas dans le formulaire : ils ne changent que par une action, qui écrit toujours dans l'historique.</a:t>
+            </a:r>
+            <a:endParaRPr lang="en-US" sz="1250" dirty="0"/>
+          </a:p>
+        </p:txBody>
+      </p:sp>
+      <p:sp>
+        <p:nvSpPr>
+          <p:cNvPr id="15" name="Shape 12"/>
           <p:cNvSpPr/>
           <p:nvPr/>
         </p:nvSpPr>
         <p:spPr>
           <a:xfrm>
-            <a:off x="2793492" y="1783080"/>
-            <a:ext cx="2103120" cy="2011680"/>
+            <a:off x="548640" y="2999232"/>
+            <a:ext cx="11094415" cy="822960"/>
           </a:xfrm>
           <a:prstGeom prst="rect">
             <a:avLst/>
@@ -8078,108 +8065,108 @@
       </p:sp>
       <p:sp>
         <p:nvSpPr>
-          <p:cNvPr id="14" name="Text 11"/>
-          <p:cNvSpPr txBox="1"/>
-          <p:nvPr/>
-        </p:nvSpPr>
-        <p:spPr>
-          <a:xfrm>
-            <a:off x="2994660" y="1984248"/>
-            <a:ext cx="914400" cy="365760"/>
-          </a:xfrm>
-          <a:prstGeom prst="rect">
-            <a:avLst/>
-          </a:prstGeom>
-          <a:noFill/>
-          <a:ln/>
-        </p:spPr>
-        <p:txBody>
-          <a:bodyPr wrap="square" lIns="0" tIns="0" rIns="0" bIns="0" rtlCol="0" anchor="t"/>
-          <a:lstStyle/>
-          <a:p>
-            <a:pPr indent="0" marL="0">
-              <a:buNone/>
-            </a:pPr>
-            <a:r>
-              <a:rPr lang="en-US" sz="2600" dirty="0">
-                <a:solidFill>
-                  <a:srgbClr val="1F4A3A"/>
+          <p:cNvPr id="16" name="Text 13"/>
+          <p:cNvSpPr txBox="1"/>
+          <p:nvPr/>
+        </p:nvSpPr>
+        <p:spPr>
+          <a:xfrm>
+            <a:off x="822960" y="2999232"/>
+            <a:ext cx="3931920" cy="822960"/>
+          </a:xfrm>
+          <a:prstGeom prst="rect">
+            <a:avLst/>
+          </a:prstGeom>
+          <a:noFill/>
+          <a:ln/>
+        </p:spPr>
+        <p:txBody>
+          <a:bodyPr wrap="square" lIns="0" tIns="0" rIns="0" bIns="0" rtlCol="0" anchor="ctr"/>
+          <a:lstStyle/>
+          <a:p>
+            <a:pPr indent="0" marL="0">
+              <a:buNone/>
+            </a:pPr>
+            <a:r>
+              <a:rPr lang="en-US" sz="1550" dirty="0">
+                <a:solidFill>
+                  <a:srgbClr val="17211C"/>
                 </a:solidFill>
                 <a:latin typeface="Georgia" pitchFamily="34" charset="0"/>
                 <a:ea typeface="Georgia" pitchFamily="34" charset="-122"/>
                 <a:cs typeface="Georgia" pitchFamily="34" charset="-120"/>
               </a:rPr>
-              <a:t>02</a:t>
-            </a:r>
-            <a:endParaRPr lang="en-US" sz="2600" dirty="0"/>
-          </a:p>
-        </p:txBody>
-      </p:sp>
-      <p:sp>
-        <p:nvSpPr>
-          <p:cNvPr id="15" name="Text 12"/>
-          <p:cNvSpPr txBox="1"/>
-          <p:nvPr/>
-        </p:nvSpPr>
-        <p:spPr>
-          <a:xfrm>
-            <a:off x="2994660" y="2496312"/>
-            <a:ext cx="1737360" cy="320040"/>
-          </a:xfrm>
-          <a:prstGeom prst="rect">
-            <a:avLst/>
-          </a:prstGeom>
-          <a:noFill/>
-          <a:ln/>
-        </p:spPr>
-        <p:txBody>
-          <a:bodyPr wrap="square" lIns="0" tIns="0" rIns="0" bIns="0" rtlCol="0" anchor="t"/>
-          <a:lstStyle/>
-          <a:p>
-            <a:pPr indent="0" marL="0">
-              <a:buNone/>
-            </a:pPr>
-            <a:r>
-              <a:rPr lang="en-US" sz="1500" b="1" dirty="0">
-                <a:solidFill>
-                  <a:srgbClr val="17211C"/>
+              <a:t>Un matériel change pendant un transfert</a:t>
+            </a:r>
+            <a:endParaRPr lang="en-US" sz="1550" dirty="0"/>
+          </a:p>
+        </p:txBody>
+      </p:sp>
+      <p:sp>
+        <p:nvSpPr>
+          <p:cNvPr id="17" name="Text 14"/>
+          <p:cNvSpPr txBox="1"/>
+          <p:nvPr/>
+        </p:nvSpPr>
+        <p:spPr>
+          <a:xfrm>
+            <a:off x="4526280" y="2999232"/>
+            <a:ext cx="365760" cy="822960"/>
+          </a:xfrm>
+          <a:prstGeom prst="rect">
+            <a:avLst/>
+          </a:prstGeom>
+          <a:noFill/>
+          <a:ln/>
+        </p:spPr>
+        <p:txBody>
+          <a:bodyPr wrap="square" lIns="0" tIns="0" rIns="0" bIns="0" rtlCol="0" anchor="ctr"/>
+          <a:lstStyle/>
+          <a:p>
+            <a:pPr algn="ctr" indent="0" marL="0">
+              <a:buNone/>
+            </a:pPr>
+            <a:r>
+              <a:rPr lang="en-US" sz="1800" dirty="0">
+                <a:solidFill>
+                  <a:srgbClr val="767A71"/>
                 </a:solidFill>
                 <a:latin typeface="Calibri" pitchFamily="34" charset="0"/>
                 <a:ea typeface="Calibri" pitchFamily="34" charset="-122"/>
                 <a:cs typeface="Calibri" pitchFamily="34" charset="-120"/>
               </a:rPr>
-              <a:t>Importer</a:t>
-            </a:r>
-            <a:endParaRPr lang="en-US" sz="1500" dirty="0"/>
-          </a:p>
-        </p:txBody>
-      </p:sp>
-      <p:sp>
-        <p:nvSpPr>
-          <p:cNvPr id="16" name="Text 13"/>
-          <p:cNvSpPr txBox="1"/>
-          <p:nvPr/>
-        </p:nvSpPr>
-        <p:spPr>
-          <a:xfrm>
-            <a:off x="2994660" y="2834640"/>
-            <a:ext cx="1737360" cy="868680"/>
-          </a:xfrm>
-          <a:prstGeom prst="rect">
-            <a:avLst/>
-          </a:prstGeom>
-          <a:noFill/>
-          <a:ln/>
-        </p:spPr>
-        <p:txBody>
-          <a:bodyPr wrap="square" lIns="0" tIns="0" rIns="0" bIns="0" rtlCol="0" anchor="t"/>
-          <a:lstStyle/>
-          <a:p>
-            <a:pPr indent="0" marL="0">
-              <a:buNone/>
-            </a:pPr>
-            <a:r>
-              <a:rPr lang="en-US" sz="1150" dirty="0">
+              <a:t>→</a:t>
+            </a:r>
+            <a:endParaRPr lang="en-US" sz="1800" dirty="0"/>
+          </a:p>
+        </p:txBody>
+      </p:sp>
+      <p:sp>
+        <p:nvSpPr>
+          <p:cNvPr id="18" name="Text 15"/>
+          <p:cNvSpPr txBox="1"/>
+          <p:nvPr/>
+        </p:nvSpPr>
+        <p:spPr>
+          <a:xfrm>
+            <a:off x="5074920" y="2999232"/>
+            <a:ext cx="6400800" cy="822960"/>
+          </a:xfrm>
+          <a:prstGeom prst="rect">
+            <a:avLst/>
+          </a:prstGeom>
+          <a:noFill/>
+          <a:ln/>
+        </p:spPr>
+        <p:txBody>
+          <a:bodyPr wrap="square" lIns="0" tIns="0" rIns="0" bIns="0" rtlCol="0" anchor="ctr"/>
+          <a:lstStyle/>
+          <a:p>
+            <a:pPr indent="0" marL="0">
+              <a:buNone/>
+            </a:pPr>
+            <a:r>
+              <a:rPr lang="en-US" sz="1250" dirty="0">
                 <a:solidFill>
                   <a:srgbClr val="3F4842"/>
                 </a:solidFill>
@@ -8187,22 +8174,22 @@
                 <a:ea typeface="Calibri" pitchFamily="34" charset="-122"/>
                 <a:cs typeface="Calibri" pitchFamily="34" charset="-120"/>
               </a:rPr>
-              <a:t>phpMyAdmin → patrimo.sql</a:t>
-            </a:r>
-            <a:endParaRPr lang="en-US" sz="1150" dirty="0"/>
-          </a:p>
-        </p:txBody>
-      </p:sp>
-      <p:sp>
-        <p:nvSpPr>
-          <p:cNvPr id="17" name="Shape 14"/>
+              <a:t>À la dernière validation, on revérifie la direction et l'état ; si ça a bougé, la demande est annulée.</a:t>
+            </a:r>
+            <a:endParaRPr lang="en-US" sz="1250" dirty="0"/>
+          </a:p>
+        </p:txBody>
+      </p:sp>
+      <p:sp>
+        <p:nvSpPr>
+          <p:cNvPr id="19" name="Shape 16"/>
           <p:cNvSpPr/>
           <p:nvPr/>
         </p:nvSpPr>
         <p:spPr>
           <a:xfrm>
-            <a:off x="5038344" y="1783080"/>
-            <a:ext cx="2103120" cy="2011680"/>
+            <a:off x="548640" y="3986784"/>
+            <a:ext cx="11094415" cy="822960"/>
           </a:xfrm>
           <a:prstGeom prst="rect">
             <a:avLst/>
@@ -8227,108 +8214,108 @@
       </p:sp>
       <p:sp>
         <p:nvSpPr>
-          <p:cNvPr id="18" name="Text 15"/>
-          <p:cNvSpPr txBox="1"/>
-          <p:nvPr/>
-        </p:nvSpPr>
-        <p:spPr>
-          <a:xfrm>
-            <a:off x="5239512" y="1984248"/>
-            <a:ext cx="914400" cy="365760"/>
-          </a:xfrm>
-          <a:prstGeom prst="rect">
-            <a:avLst/>
-          </a:prstGeom>
-          <a:noFill/>
-          <a:ln/>
-        </p:spPr>
-        <p:txBody>
-          <a:bodyPr wrap="square" lIns="0" tIns="0" rIns="0" bIns="0" rtlCol="0" anchor="t"/>
-          <a:lstStyle/>
-          <a:p>
-            <a:pPr indent="0" marL="0">
-              <a:buNone/>
-            </a:pPr>
-            <a:r>
-              <a:rPr lang="en-US" sz="2600" dirty="0">
-                <a:solidFill>
-                  <a:srgbClr val="1F4A3A"/>
+          <p:cNvPr id="20" name="Text 17"/>
+          <p:cNvSpPr txBox="1"/>
+          <p:nvPr/>
+        </p:nvSpPr>
+        <p:spPr>
+          <a:xfrm>
+            <a:off x="822960" y="3986784"/>
+            <a:ext cx="3931920" cy="822960"/>
+          </a:xfrm>
+          <a:prstGeom prst="rect">
+            <a:avLst/>
+          </a:prstGeom>
+          <a:noFill/>
+          <a:ln/>
+        </p:spPr>
+        <p:txBody>
+          <a:bodyPr wrap="square" lIns="0" tIns="0" rIns="0" bIns="0" rtlCol="0" anchor="ctr"/>
+          <a:lstStyle/>
+          <a:p>
+            <a:pPr indent="0" marL="0">
+              <a:buNone/>
+            </a:pPr>
+            <a:r>
+              <a:rPr lang="en-US" sz="1550" dirty="0">
+                <a:solidFill>
+                  <a:srgbClr val="17211C"/>
                 </a:solidFill>
                 <a:latin typeface="Georgia" pitchFamily="34" charset="0"/>
                 <a:ea typeface="Georgia" pitchFamily="34" charset="-122"/>
                 <a:cs typeface="Georgia" pitchFamily="34" charset="-120"/>
               </a:rPr>
-              <a:t>03</a:t>
-            </a:r>
-            <a:endParaRPr lang="en-US" sz="2600" dirty="0"/>
-          </a:p>
-        </p:txBody>
-      </p:sp>
-      <p:sp>
-        <p:nvSpPr>
-          <p:cNvPr id="19" name="Text 16"/>
-          <p:cNvSpPr txBox="1"/>
-          <p:nvPr/>
-        </p:nvSpPr>
-        <p:spPr>
-          <a:xfrm>
-            <a:off x="5239512" y="2496312"/>
-            <a:ext cx="1737360" cy="320040"/>
-          </a:xfrm>
-          <a:prstGeom prst="rect">
-            <a:avLst/>
-          </a:prstGeom>
-          <a:noFill/>
-          <a:ln/>
-        </p:spPr>
-        <p:txBody>
-          <a:bodyPr wrap="square" lIns="0" tIns="0" rIns="0" bIns="0" rtlCol="0" anchor="t"/>
-          <a:lstStyle/>
-          <a:p>
-            <a:pPr indent="0" marL="0">
-              <a:buNone/>
-            </a:pPr>
-            <a:r>
-              <a:rPr lang="en-US" sz="1500" b="1" dirty="0">
-                <a:solidFill>
-                  <a:srgbClr val="17211C"/>
+              <a:t>Requêtes refusées en MySQL strict</a:t>
+            </a:r>
+            <a:endParaRPr lang="en-US" sz="1550" dirty="0"/>
+          </a:p>
+        </p:txBody>
+      </p:sp>
+      <p:sp>
+        <p:nvSpPr>
+          <p:cNvPr id="21" name="Text 18"/>
+          <p:cNvSpPr txBox="1"/>
+          <p:nvPr/>
+        </p:nvSpPr>
+        <p:spPr>
+          <a:xfrm>
+            <a:off x="4526280" y="3986784"/>
+            <a:ext cx="365760" cy="822960"/>
+          </a:xfrm>
+          <a:prstGeom prst="rect">
+            <a:avLst/>
+          </a:prstGeom>
+          <a:noFill/>
+          <a:ln/>
+        </p:spPr>
+        <p:txBody>
+          <a:bodyPr wrap="square" lIns="0" tIns="0" rIns="0" bIns="0" rtlCol="0" anchor="ctr"/>
+          <a:lstStyle/>
+          <a:p>
+            <a:pPr algn="ctr" indent="0" marL="0">
+              <a:buNone/>
+            </a:pPr>
+            <a:r>
+              <a:rPr lang="en-US" sz="1800" dirty="0">
+                <a:solidFill>
+                  <a:srgbClr val="767A71"/>
                 </a:solidFill>
                 <a:latin typeface="Calibri" pitchFamily="34" charset="0"/>
                 <a:ea typeface="Calibri" pitchFamily="34" charset="-122"/>
                 <a:cs typeface="Calibri" pitchFamily="34" charset="-120"/>
               </a:rPr>
-              <a:t>Configurer</a:t>
-            </a:r>
-            <a:endParaRPr lang="en-US" sz="1500" dirty="0"/>
-          </a:p>
-        </p:txBody>
-      </p:sp>
-      <p:sp>
-        <p:nvSpPr>
-          <p:cNvPr id="20" name="Text 17"/>
-          <p:cNvSpPr txBox="1"/>
-          <p:nvPr/>
-        </p:nvSpPr>
-        <p:spPr>
-          <a:xfrm>
-            <a:off x="5239512" y="2834640"/>
-            <a:ext cx="1737360" cy="868680"/>
-          </a:xfrm>
-          <a:prstGeom prst="rect">
-            <a:avLst/>
-          </a:prstGeom>
-          <a:noFill/>
-          <a:ln/>
-        </p:spPr>
-        <p:txBody>
-          <a:bodyPr wrap="square" lIns="0" tIns="0" rIns="0" bIns="0" rtlCol="0" anchor="t"/>
-          <a:lstStyle/>
-          <a:p>
-            <a:pPr indent="0" marL="0">
-              <a:buNone/>
-            </a:pPr>
-            <a:r>
-              <a:rPr lang="en-US" sz="1150" dirty="0">
+              <a:t>→</a:t>
+            </a:r>
+            <a:endParaRPr lang="en-US" sz="1800" dirty="0"/>
+          </a:p>
+        </p:txBody>
+      </p:sp>
+      <p:sp>
+        <p:nvSpPr>
+          <p:cNvPr id="22" name="Text 19"/>
+          <p:cNvSpPr txBox="1"/>
+          <p:nvPr/>
+        </p:nvSpPr>
+        <p:spPr>
+          <a:xfrm>
+            <a:off x="5074920" y="3986784"/>
+            <a:ext cx="6400800" cy="822960"/>
+          </a:xfrm>
+          <a:prstGeom prst="rect">
+            <a:avLst/>
+          </a:prstGeom>
+          <a:noFill/>
+          <a:ln/>
+        </p:spPr>
+        <p:txBody>
+          <a:bodyPr wrap="square" lIns="0" tIns="0" rIns="0" bIns="0" rtlCol="0" anchor="ctr"/>
+          <a:lstStyle/>
+          <a:p>
+            <a:pPr indent="0" marL="0">
+              <a:buNone/>
+            </a:pPr>
+            <a:r>
+              <a:rPr lang="en-US" sz="1250" dirty="0">
                 <a:solidFill>
                   <a:srgbClr val="3F4842"/>
                 </a:solidFill>
@@ -8336,22 +8323,22 @@
                 <a:ea typeface="Calibri" pitchFamily="34" charset="-122"/>
                 <a:cs typeface="Calibri" pitchFamily="34" charset="-120"/>
               </a:rPr>
-              <a:t>includes/config.php : hôte, base, utilisateur, mot de passe</a:t>
-            </a:r>
-            <a:endParaRPr lang="en-US" sz="1150" dirty="0"/>
-          </a:p>
-        </p:txBody>
-      </p:sp>
-      <p:sp>
-        <p:nvSpPr>
-          <p:cNvPr id="21" name="Shape 18"/>
+              <a:t>GROUP BY complété avec toutes les colonnes affichées : même résultat, compatible partout.</a:t>
+            </a:r>
+            <a:endParaRPr lang="en-US" sz="1250" dirty="0"/>
+          </a:p>
+        </p:txBody>
+      </p:sp>
+      <p:sp>
+        <p:nvSpPr>
+          <p:cNvPr id="23" name="Shape 20"/>
           <p:cNvSpPr/>
           <p:nvPr/>
         </p:nvSpPr>
         <p:spPr>
           <a:xfrm>
-            <a:off x="7283196" y="1783080"/>
-            <a:ext cx="2103120" cy="2011680"/>
+            <a:off x="548640" y="4974336"/>
+            <a:ext cx="11094415" cy="822960"/>
           </a:xfrm>
           <a:prstGeom prst="rect">
             <a:avLst/>
@@ -8376,108 +8363,108 @@
       </p:sp>
       <p:sp>
         <p:nvSpPr>
-          <p:cNvPr id="22" name="Text 19"/>
-          <p:cNvSpPr txBox="1"/>
-          <p:nvPr/>
-        </p:nvSpPr>
-        <p:spPr>
-          <a:xfrm>
-            <a:off x="7484364" y="1984248"/>
-            <a:ext cx="914400" cy="365760"/>
-          </a:xfrm>
-          <a:prstGeom prst="rect">
-            <a:avLst/>
-          </a:prstGeom>
-          <a:noFill/>
-          <a:ln/>
-        </p:spPr>
-        <p:txBody>
-          <a:bodyPr wrap="square" lIns="0" tIns="0" rIns="0" bIns="0" rtlCol="0" anchor="t"/>
-          <a:lstStyle/>
-          <a:p>
-            <a:pPr indent="0" marL="0">
-              <a:buNone/>
-            </a:pPr>
-            <a:r>
-              <a:rPr lang="en-US" sz="2600" dirty="0">
-                <a:solidFill>
-                  <a:srgbClr val="1F4A3A"/>
+          <p:cNvPr id="24" name="Text 21"/>
+          <p:cNvSpPr txBox="1"/>
+          <p:nvPr/>
+        </p:nvSpPr>
+        <p:spPr>
+          <a:xfrm>
+            <a:off x="822960" y="4974336"/>
+            <a:ext cx="3931920" cy="822960"/>
+          </a:xfrm>
+          <a:prstGeom prst="rect">
+            <a:avLst/>
+          </a:prstGeom>
+          <a:noFill/>
+          <a:ln/>
+        </p:spPr>
+        <p:txBody>
+          <a:bodyPr wrap="square" lIns="0" tIns="0" rIns="0" bIns="0" rtlCol="0" anchor="ctr"/>
+          <a:lstStyle/>
+          <a:p>
+            <a:pPr indent="0" marL="0">
+              <a:buNone/>
+            </a:pPr>
+            <a:r>
+              <a:rPr lang="en-US" sz="1550" dirty="0">
+                <a:solidFill>
+                  <a:srgbClr val="17211C"/>
                 </a:solidFill>
                 <a:latin typeface="Georgia" pitchFamily="34" charset="0"/>
                 <a:ea typeface="Georgia" pitchFamily="34" charset="-122"/>
                 <a:cs typeface="Georgia" pitchFamily="34" charset="-120"/>
               </a:rPr>
-              <a:t>04</a:t>
-            </a:r>
-            <a:endParaRPr lang="en-US" sz="2600" dirty="0"/>
-          </a:p>
-        </p:txBody>
-      </p:sp>
-      <p:sp>
-        <p:nvSpPr>
-          <p:cNvPr id="23" name="Text 20"/>
-          <p:cNvSpPr txBox="1"/>
-          <p:nvPr/>
-        </p:nvSpPr>
-        <p:spPr>
-          <a:xfrm>
-            <a:off x="7484364" y="2496312"/>
-            <a:ext cx="1737360" cy="320040"/>
-          </a:xfrm>
-          <a:prstGeom prst="rect">
-            <a:avLst/>
-          </a:prstGeom>
-          <a:noFill/>
-          <a:ln/>
-        </p:spPr>
-        <p:txBody>
-          <a:bodyPr wrap="square" lIns="0" tIns="0" rIns="0" bIns="0" rtlCol="0" anchor="t"/>
-          <a:lstStyle/>
-          <a:p>
-            <a:pPr indent="0" marL="0">
-              <a:buNone/>
-            </a:pPr>
-            <a:r>
-              <a:rPr lang="en-US" sz="1500" b="1" dirty="0">
-                <a:solidFill>
-                  <a:srgbClr val="17211C"/>
+              <a:t>Export CSV pollué (PHP 8.4)</a:t>
+            </a:r>
+            <a:endParaRPr lang="en-US" sz="1550" dirty="0"/>
+          </a:p>
+        </p:txBody>
+      </p:sp>
+      <p:sp>
+        <p:nvSpPr>
+          <p:cNvPr id="25" name="Text 22"/>
+          <p:cNvSpPr txBox="1"/>
+          <p:nvPr/>
+        </p:nvSpPr>
+        <p:spPr>
+          <a:xfrm>
+            <a:off x="4526280" y="4974336"/>
+            <a:ext cx="365760" cy="822960"/>
+          </a:xfrm>
+          <a:prstGeom prst="rect">
+            <a:avLst/>
+          </a:prstGeom>
+          <a:noFill/>
+          <a:ln/>
+        </p:spPr>
+        <p:txBody>
+          <a:bodyPr wrap="square" lIns="0" tIns="0" rIns="0" bIns="0" rtlCol="0" anchor="ctr"/>
+          <a:lstStyle/>
+          <a:p>
+            <a:pPr algn="ctr" indent="0" marL="0">
+              <a:buNone/>
+            </a:pPr>
+            <a:r>
+              <a:rPr lang="en-US" sz="1800" dirty="0">
+                <a:solidFill>
+                  <a:srgbClr val="767A71"/>
                 </a:solidFill>
                 <a:latin typeface="Calibri" pitchFamily="34" charset="0"/>
                 <a:ea typeface="Calibri" pitchFamily="34" charset="-122"/>
                 <a:cs typeface="Calibri" pitchFamily="34" charset="-120"/>
               </a:rPr>
-              <a:t>Envoyer</a:t>
-            </a:r>
-            <a:endParaRPr lang="en-US" sz="1500" dirty="0"/>
-          </a:p>
-        </p:txBody>
-      </p:sp>
-      <p:sp>
-        <p:nvSpPr>
-          <p:cNvPr id="24" name="Text 21"/>
-          <p:cNvSpPr txBox="1"/>
-          <p:nvPr/>
-        </p:nvSpPr>
-        <p:spPr>
-          <a:xfrm>
-            <a:off x="7484364" y="2834640"/>
-            <a:ext cx="1737360" cy="868680"/>
-          </a:xfrm>
-          <a:prstGeom prst="rect">
-            <a:avLst/>
-          </a:prstGeom>
-          <a:noFill/>
-          <a:ln/>
-        </p:spPr>
-        <p:txBody>
-          <a:bodyPr wrap="square" lIns="0" tIns="0" rIns="0" bIns="0" rtlCol="0" anchor="t"/>
-          <a:lstStyle/>
-          <a:p>
-            <a:pPr indent="0" marL="0">
-              <a:buNone/>
-            </a:pPr>
-            <a:r>
-              <a:rPr lang="en-US" sz="1150" dirty="0">
+              <a:t>→</a:t>
+            </a:r>
+            <a:endParaRPr lang="en-US" sz="1800" dirty="0"/>
+          </a:p>
+        </p:txBody>
+      </p:sp>
+      <p:sp>
+        <p:nvSpPr>
+          <p:cNvPr id="26" name="Text 23"/>
+          <p:cNvSpPr txBox="1"/>
+          <p:nvPr/>
+        </p:nvSpPr>
+        <p:spPr>
+          <a:xfrm>
+            <a:off x="5074920" y="4974336"/>
+            <a:ext cx="6400800" cy="822960"/>
+          </a:xfrm>
+          <a:prstGeom prst="rect">
+            <a:avLst/>
+          </a:prstGeom>
+          <a:noFill/>
+          <a:ln/>
+        </p:spPr>
+        <p:txBody>
+          <a:bodyPr wrap="square" lIns="0" tIns="0" rIns="0" bIns="0" rtlCol="0" anchor="ctr"/>
+          <a:lstStyle/>
+          <a:p>
+            <a:pPr indent="0" marL="0">
+              <a:buNone/>
+            </a:pPr>
+            <a:r>
+              <a:rPr lang="en-US" sz="1250" dirty="0">
                 <a:solidFill>
                   <a:srgbClr val="3F4842"/>
                 </a:solidFill>
@@ -8485,522 +8472,9 @@
                 <a:ea typeface="Calibri" pitchFamily="34" charset="-122"/>
                 <a:cs typeface="Calibri" pitchFamily="34" charset="-120"/>
               </a:rPr>
-              <a:t>Contenu du dossier htdocs/ par le gestionnaire de fichiers ou FTP</a:t>
-            </a:r>
-            <a:endParaRPr lang="en-US" sz="1150" dirty="0"/>
-          </a:p>
-        </p:txBody>
-      </p:sp>
-      <p:sp>
-        <p:nvSpPr>
-          <p:cNvPr id="25" name="Shape 22"/>
-          <p:cNvSpPr/>
-          <p:nvPr/>
-        </p:nvSpPr>
-        <p:spPr>
-          <a:xfrm>
-            <a:off x="9528048" y="1783080"/>
-            <a:ext cx="2103120" cy="2011680"/>
-          </a:xfrm>
-          <a:prstGeom prst="rect">
-            <a:avLst/>
-          </a:prstGeom>
-          <a:solidFill>
-            <a:srgbClr val="FBF9F4"/>
-          </a:solidFill>
-          <a:ln w="9525">
-            <a:solidFill>
-              <a:srgbClr val="DCD5C6"/>
-            </a:solidFill>
-            <a:prstDash val="solid"/>
-          </a:ln>
-          <a:effectLst>
-            <a:outerShdw sx="100000" sy="100000" kx="0" ky="0" algn="bl" rotWithShape="0" blurRad="76200" dist="19050" dir="5400000">
-              <a:srgbClr val="1A2E25">
-                <a:alpha val="8000"/>
-              </a:srgbClr>
-            </a:outerShdw>
-          </a:effectLst>
-        </p:spPr>
-      </p:sp>
-      <p:sp>
-        <p:nvSpPr>
-          <p:cNvPr id="26" name="Text 23"/>
-          <p:cNvSpPr txBox="1"/>
-          <p:nvPr/>
-        </p:nvSpPr>
-        <p:spPr>
-          <a:xfrm>
-            <a:off x="9729216" y="1984248"/>
-            <a:ext cx="914400" cy="365760"/>
-          </a:xfrm>
-          <a:prstGeom prst="rect">
-            <a:avLst/>
-          </a:prstGeom>
-          <a:noFill/>
-          <a:ln/>
-        </p:spPr>
-        <p:txBody>
-          <a:bodyPr wrap="square" lIns="0" tIns="0" rIns="0" bIns="0" rtlCol="0" anchor="t"/>
-          <a:lstStyle/>
-          <a:p>
-            <a:pPr indent="0" marL="0">
-              <a:buNone/>
-            </a:pPr>
-            <a:r>
-              <a:rPr lang="en-US" sz="2600" dirty="0">
-                <a:solidFill>
-                  <a:srgbClr val="1F4A3A"/>
-                </a:solidFill>
-                <a:latin typeface="Georgia" pitchFamily="34" charset="0"/>
-                <a:ea typeface="Georgia" pitchFamily="34" charset="-122"/>
-                <a:cs typeface="Georgia" pitchFamily="34" charset="-120"/>
-              </a:rPr>
-              <a:t>05</a:t>
-            </a:r>
-            <a:endParaRPr lang="en-US" sz="2600" dirty="0"/>
-          </a:p>
-        </p:txBody>
-      </p:sp>
-      <p:sp>
-        <p:nvSpPr>
-          <p:cNvPr id="27" name="Text 24"/>
-          <p:cNvSpPr txBox="1"/>
-          <p:nvPr/>
-        </p:nvSpPr>
-        <p:spPr>
-          <a:xfrm>
-            <a:off x="9729216" y="2496312"/>
-            <a:ext cx="1737360" cy="320040"/>
-          </a:xfrm>
-          <a:prstGeom prst="rect">
-            <a:avLst/>
-          </a:prstGeom>
-          <a:noFill/>
-          <a:ln/>
-        </p:spPr>
-        <p:txBody>
-          <a:bodyPr wrap="square" lIns="0" tIns="0" rIns="0" bIns="0" rtlCol="0" anchor="t"/>
-          <a:lstStyle/>
-          <a:p>
-            <a:pPr indent="0" marL="0">
-              <a:buNone/>
-            </a:pPr>
-            <a:r>
-              <a:rPr lang="en-US" sz="1500" b="1" dirty="0">
-                <a:solidFill>
-                  <a:srgbClr val="17211C"/>
-                </a:solidFill>
-                <a:latin typeface="Calibri" pitchFamily="34" charset="0"/>
-                <a:ea typeface="Calibri" pitchFamily="34" charset="-122"/>
-                <a:cs typeface="Calibri" pitchFamily="34" charset="-120"/>
-              </a:rPr>
-              <a:t>Sécuriser</a:t>
-            </a:r>
-            <a:endParaRPr lang="en-US" sz="1500" dirty="0"/>
-          </a:p>
-        </p:txBody>
-      </p:sp>
-      <p:sp>
-        <p:nvSpPr>
-          <p:cNvPr id="28" name="Text 25"/>
-          <p:cNvSpPr txBox="1"/>
-          <p:nvPr/>
-        </p:nvSpPr>
-        <p:spPr>
-          <a:xfrm>
-            <a:off x="9729216" y="2834640"/>
-            <a:ext cx="1737360" cy="868680"/>
-          </a:xfrm>
-          <a:prstGeom prst="rect">
-            <a:avLst/>
-          </a:prstGeom>
-          <a:noFill/>
-          <a:ln/>
-        </p:spPr>
-        <p:txBody>
-          <a:bodyPr wrap="square" lIns="0" tIns="0" rIns="0" bIns="0" rtlCol="0" anchor="t"/>
-          <a:lstStyle/>
-          <a:p>
-            <a:pPr indent="0" marL="0">
-              <a:buNone/>
-            </a:pPr>
-            <a:r>
-              <a:rPr lang="en-US" sz="1150" dirty="0">
-                <a:solidFill>
-                  <a:srgbClr val="3F4842"/>
-                </a:solidFill>
-                <a:latin typeface="Calibri" pitchFamily="34" charset="0"/>
-                <a:ea typeface="Calibri" pitchFamily="34" charset="-122"/>
-                <a:cs typeface="Calibri" pitchFamily="34" charset="-120"/>
-              </a:rPr>
-              <a:t>Certificat SSL gratuit, puis changement des mots de passe</a:t>
-            </a:r>
-            <a:endParaRPr lang="en-US" sz="1150" dirty="0"/>
-          </a:p>
-        </p:txBody>
-      </p:sp>
-      <p:sp>
-        <p:nvSpPr>
-          <p:cNvPr id="29" name="Text 26"/>
-          <p:cNvSpPr txBox="1"/>
-          <p:nvPr/>
-        </p:nvSpPr>
-        <p:spPr>
-          <a:xfrm>
-            <a:off x="548640" y="4160520"/>
-            <a:ext cx="5486400" cy="228600"/>
-          </a:xfrm>
-          <a:prstGeom prst="rect">
-            <a:avLst/>
-          </a:prstGeom>
-          <a:noFill/>
-          <a:ln/>
-        </p:spPr>
-        <p:txBody>
-          <a:bodyPr wrap="square" lIns="0" tIns="0" rIns="0" bIns="0" rtlCol="0" anchor="t"/>
-          <a:lstStyle/>
-          <a:p>
-            <a:pPr indent="0" marL="0">
-              <a:buNone/>
-            </a:pPr>
-            <a:r>
-              <a:rPr lang="en-US" sz="1000" b="1" spc="200" kern="0" dirty="0">
-                <a:solidFill>
-                  <a:srgbClr val="1F4A3A"/>
-                </a:solidFill>
-                <a:latin typeface="Consolas" pitchFamily="34" charset="0"/>
-                <a:ea typeface="Consolas" pitchFamily="34" charset="-122"/>
-                <a:cs typeface="Consolas" pitchFamily="34" charset="-120"/>
-              </a:rPr>
-              <a:t>ADAPTATIONS À L'HÉBERGEUR GRATUIT</a:t>
-            </a:r>
-            <a:endParaRPr lang="en-US" sz="1000" dirty="0"/>
-          </a:p>
-        </p:txBody>
-      </p:sp>
-      <p:sp>
-        <p:nvSpPr>
-          <p:cNvPr id="30" name="Text 27"/>
-          <p:cNvSpPr txBox="1"/>
-          <p:nvPr/>
-        </p:nvSpPr>
-        <p:spPr>
-          <a:xfrm>
-            <a:off x="548640" y="4526280"/>
-            <a:ext cx="3520440" cy="292608"/>
-          </a:xfrm>
-          <a:prstGeom prst="rect">
-            <a:avLst/>
-          </a:prstGeom>
-          <a:noFill/>
-          <a:ln/>
-        </p:spPr>
-        <p:txBody>
-          <a:bodyPr wrap="square" lIns="0" tIns="0" rIns="0" bIns="0" rtlCol="0" anchor="t"/>
-          <a:lstStyle/>
-          <a:p>
-            <a:pPr indent="0" marL="0">
-              <a:buNone/>
-            </a:pPr>
-            <a:r>
-              <a:rPr lang="en-US" sz="1400" b="1" dirty="0">
-                <a:solidFill>
-                  <a:srgbClr val="17211C"/>
-                </a:solidFill>
-                <a:latin typeface="Calibri" pitchFamily="34" charset="0"/>
-                <a:ea typeface="Calibri" pitchFamily="34" charset="-122"/>
-                <a:cs typeface="Calibri" pitchFamily="34" charset="-120"/>
-              </a:rPr>
-              <a:t>Dates en français sans intl</a:t>
-            </a:r>
-            <a:endParaRPr lang="en-US" sz="1400" dirty="0"/>
-          </a:p>
-        </p:txBody>
-      </p:sp>
-      <p:sp>
-        <p:nvSpPr>
-          <p:cNvPr id="31" name="Text 28"/>
-          <p:cNvSpPr txBox="1"/>
-          <p:nvPr/>
-        </p:nvSpPr>
-        <p:spPr>
-          <a:xfrm>
-            <a:off x="548640" y="4846320"/>
-            <a:ext cx="3474720" cy="731520"/>
-          </a:xfrm>
-          <a:prstGeom prst="rect">
-            <a:avLst/>
-          </a:prstGeom>
-          <a:noFill/>
-          <a:ln/>
-        </p:spPr>
-        <p:txBody>
-          <a:bodyPr wrap="square" lIns="0" tIns="0" rIns="0" bIns="0" rtlCol="0" anchor="t"/>
-          <a:lstStyle/>
-          <a:p>
-            <a:pPr indent="0" marL="0">
-              <a:buNone/>
-            </a:pPr>
-            <a:r>
-              <a:rPr lang="en-US" sz="1200" dirty="0">
-                <a:solidFill>
-                  <a:srgbClr val="3F4842"/>
-                </a:solidFill>
-                <a:latin typeface="Calibri" pitchFamily="34" charset="0"/>
-                <a:ea typeface="Calibri" pitchFamily="34" charset="-122"/>
-                <a:cs typeface="Calibri" pitchFamily="34" charset="-120"/>
-              </a:rPr>
-              <a:t>L'extension n'est pas toujours activée : jours et mois sont traduits dans le code.</a:t>
-            </a:r>
-            <a:endParaRPr lang="en-US" sz="1200" dirty="0"/>
-          </a:p>
-        </p:txBody>
-      </p:sp>
-      <p:sp>
-        <p:nvSpPr>
-          <p:cNvPr id="32" name="Text 29"/>
-          <p:cNvSpPr txBox="1"/>
-          <p:nvPr/>
-        </p:nvSpPr>
-        <p:spPr>
-          <a:xfrm>
-            <a:off x="4297680" y="4526280"/>
-            <a:ext cx="3520440" cy="292608"/>
-          </a:xfrm>
-          <a:prstGeom prst="rect">
-            <a:avLst/>
-          </a:prstGeom>
-          <a:noFill/>
-          <a:ln/>
-        </p:spPr>
-        <p:txBody>
-          <a:bodyPr wrap="square" lIns="0" tIns="0" rIns="0" bIns="0" rtlCol="0" anchor="t"/>
-          <a:lstStyle/>
-          <a:p>
-            <a:pPr indent="0" marL="0">
-              <a:buNone/>
-            </a:pPr>
-            <a:r>
-              <a:rPr lang="en-US" sz="1400" b="1" dirty="0">
-                <a:solidFill>
-                  <a:srgbClr val="17211C"/>
-                </a:solidFill>
-                <a:latin typeface="Calibri" pitchFamily="34" charset="0"/>
-                <a:ea typeface="Calibri" pitchFamily="34" charset="-122"/>
-                <a:cs typeface="Calibri" pitchFamily="34" charset="-120"/>
-              </a:rPr>
-              <a:t>Polices hébergées sur le site</a:t>
-            </a:r>
-            <a:endParaRPr lang="en-US" sz="1400" dirty="0"/>
-          </a:p>
-        </p:txBody>
-      </p:sp>
-      <p:sp>
-        <p:nvSpPr>
-          <p:cNvPr id="33" name="Text 30"/>
-          <p:cNvSpPr txBox="1"/>
-          <p:nvPr/>
-        </p:nvSpPr>
-        <p:spPr>
-          <a:xfrm>
-            <a:off x="4297680" y="4846320"/>
-            <a:ext cx="3474720" cy="731520"/>
-          </a:xfrm>
-          <a:prstGeom prst="rect">
-            <a:avLst/>
-          </a:prstGeom>
-          <a:noFill/>
-          <a:ln/>
-        </p:spPr>
-        <p:txBody>
-          <a:bodyPr wrap="square" lIns="0" tIns="0" rIns="0" bIns="0" rtlCol="0" anchor="t"/>
-          <a:lstStyle/>
-          <a:p>
-            <a:pPr indent="0" marL="0">
-              <a:buNone/>
-            </a:pPr>
-            <a:r>
-              <a:rPr lang="en-US" sz="1200" dirty="0">
-                <a:solidFill>
-                  <a:srgbClr val="3F4842"/>
-                </a:solidFill>
-                <a:latin typeface="Calibri" pitchFamily="34" charset="0"/>
-                <a:ea typeface="Calibri" pitchFamily="34" charset="-122"/>
-                <a:cs typeface="Calibri" pitchFamily="34" charset="-120"/>
-              </a:rPr>
-              <a:t>Aucun appel à Google Fonts : ça marche aussi en démonstration hors ligne.</a:t>
-            </a:r>
-            <a:endParaRPr lang="en-US" sz="1200" dirty="0"/>
-          </a:p>
-        </p:txBody>
-      </p:sp>
-      <p:sp>
-        <p:nvSpPr>
-          <p:cNvPr id="34" name="Text 31"/>
-          <p:cNvSpPr txBox="1"/>
-          <p:nvPr/>
-        </p:nvSpPr>
-        <p:spPr>
-          <a:xfrm>
-            <a:off x="8046720" y="4526280"/>
-            <a:ext cx="3520440" cy="292608"/>
-          </a:xfrm>
-          <a:prstGeom prst="rect">
-            <a:avLst/>
-          </a:prstGeom>
-          <a:noFill/>
-          <a:ln/>
-        </p:spPr>
-        <p:txBody>
-          <a:bodyPr wrap="square" lIns="0" tIns="0" rIns="0" bIns="0" rtlCol="0" anchor="t"/>
-          <a:lstStyle/>
-          <a:p>
-            <a:pPr indent="0" marL="0">
-              <a:buNone/>
-            </a:pPr>
-            <a:r>
-              <a:rPr lang="en-US" sz="1400" b="1" dirty="0">
-                <a:solidFill>
-                  <a:srgbClr val="17211C"/>
-                </a:solidFill>
-                <a:latin typeface="Calibri" pitchFamily="34" charset="0"/>
-                <a:ea typeface="Calibri" pitchFamily="34" charset="-122"/>
-                <a:cs typeface="Calibri" pitchFamily="34" charset="-120"/>
-              </a:rPr>
-              <a:t>Configuration locale séparée</a:t>
-            </a:r>
-            <a:endParaRPr lang="en-US" sz="1400" dirty="0"/>
-          </a:p>
-        </p:txBody>
-      </p:sp>
-      <p:sp>
-        <p:nvSpPr>
-          <p:cNvPr id="35" name="Text 32"/>
-          <p:cNvSpPr txBox="1"/>
-          <p:nvPr/>
-        </p:nvSpPr>
-        <p:spPr>
-          <a:xfrm>
-            <a:off x="8046720" y="4846320"/>
-            <a:ext cx="3474720" cy="731520"/>
-          </a:xfrm>
-          <a:prstGeom prst="rect">
-            <a:avLst/>
-          </a:prstGeom>
-          <a:noFill/>
-          <a:ln/>
-        </p:spPr>
-        <p:txBody>
-          <a:bodyPr wrap="square" lIns="0" tIns="0" rIns="0" bIns="0" rtlCol="0" anchor="t"/>
-          <a:lstStyle/>
-          <a:p>
-            <a:pPr indent="0" marL="0">
-              <a:buNone/>
-            </a:pPr>
-            <a:r>
-              <a:rPr lang="en-US" sz="1200" dirty="0">
-                <a:solidFill>
-                  <a:srgbClr val="3F4842"/>
-                </a:solidFill>
-                <a:latin typeface="Calibri" pitchFamily="34" charset="0"/>
-                <a:ea typeface="Calibri" pitchFamily="34" charset="-122"/>
-                <a:cs typeface="Calibri" pitchFamily="34" charset="-120"/>
-              </a:rPr>
-              <a:t>config.local.php (non envoyé) prend le dessus sur la configuration de production.</a:t>
-            </a:r>
-            <a:endParaRPr lang="en-US" sz="1200" dirty="0"/>
-          </a:p>
-        </p:txBody>
-      </p:sp>
-      <p:sp>
-        <p:nvSpPr>
-          <p:cNvPr id="36" name="Shape 33"/>
-          <p:cNvSpPr/>
-          <p:nvPr/>
-        </p:nvSpPr>
-        <p:spPr>
-          <a:xfrm>
-            <a:off x="548640" y="5806440"/>
-            <a:ext cx="3584448" cy="274320"/>
-          </a:xfrm>
-          <a:prstGeom prst="roundRect">
-            <a:avLst>
-              <a:gd name="adj" fmla="val 16667"/>
-            </a:avLst>
-          </a:prstGeom>
-          <a:solidFill>
-            <a:srgbClr val="FFFDF7"/>
-          </a:solidFill>
-          <a:ln w="9525">
-            <a:solidFill>
-              <a:srgbClr val="CBC2AD"/>
-            </a:solidFill>
-            <a:prstDash val="solid"/>
-          </a:ln>
-        </p:spPr>
-      </p:sp>
-      <p:sp>
-        <p:nvSpPr>
-          <p:cNvPr id="37" name="Shape 34"/>
-          <p:cNvSpPr/>
-          <p:nvPr/>
-        </p:nvSpPr>
-        <p:spPr>
-          <a:xfrm>
-            <a:off x="640080" y="5911596"/>
-            <a:ext cx="64008" cy="64008"/>
-          </a:xfrm>
-          <a:prstGeom prst="ellipse">
-            <a:avLst/>
-          </a:prstGeom>
-          <a:solidFill>
-            <a:srgbClr val="F3EFE6"/>
-          </a:solidFill>
-          <a:ln w="9525">
-            <a:solidFill>
-              <a:srgbClr val="CBC2AD"/>
-            </a:solidFill>
-            <a:prstDash val="solid"/>
-          </a:ln>
-        </p:spPr>
-      </p:sp>
-      <p:sp>
-        <p:nvSpPr>
-          <p:cNvPr id="38" name="Text 35"/>
-          <p:cNvSpPr txBox="1"/>
-          <p:nvPr/>
-        </p:nvSpPr>
-        <p:spPr>
-          <a:xfrm>
-            <a:off x="768096" y="5806440"/>
-            <a:ext cx="3346704" cy="274320"/>
-          </a:xfrm>
-          <a:prstGeom prst="rect">
-            <a:avLst/>
-          </a:prstGeom>
-          <a:noFill/>
-          <a:ln/>
-        </p:spPr>
-        <p:txBody>
-          <a:bodyPr wrap="none" lIns="0" tIns="0" rIns="0" bIns="0" rtlCol="0" anchor="ctr"/>
-          <a:lstStyle/>
-          <a:p>
-            <a:pPr indent="0" marL="0">
-              <a:buNone/>
-            </a:pPr>
-            <a:r>
-              <a:rPr lang="en-US" sz="1000" spc="100" kern="0" dirty="0">
-                <a:solidFill>
-                  <a:srgbClr val="17211C"/>
-                </a:solidFill>
-                <a:latin typeface="Consolas" pitchFamily="34" charset="0"/>
-                <a:ea typeface="Consolas" pitchFamily="34" charset="-122"/>
-                <a:cs typeface="Consolas" pitchFamily="34" charset="-120"/>
-              </a:rPr>
-              <a:t>https://patrimo.infinityfreeapp.com</a:t>
-            </a:r>
-            <a:endParaRPr lang="en-US" sz="1000" dirty="0"/>
+              <a:t>Paramètre d'échappement de fputcsv précisé explicitement ; export propre et lisible dans Excel.</a:t>
+            </a:r>
+            <a:endParaRPr lang="en-US" sz="1250" dirty="0"/>
           </a:p>
         </p:txBody>
       </p:sp>
@@ -9045,7 +8519,7 @@
         <p:spPr>
           <a:xfrm>
             <a:off x="548640" y="384048"/>
-            <a:ext cx="2578608" cy="274320"/>
+            <a:ext cx="1298448" cy="274320"/>
           </a:xfrm>
           <a:prstGeom prst="roundRect">
             <a:avLst>
@@ -9097,7 +8571,7 @@
         <p:spPr>
           <a:xfrm>
             <a:off x="768096" y="384048"/>
-            <a:ext cx="2340864" cy="274320"/>
+            <a:ext cx="1060704" cy="274320"/>
           </a:xfrm>
           <a:prstGeom prst="rect">
             <a:avLst/>
@@ -9121,7 +8595,7 @@
                 <a:ea typeface="Consolas" pitchFamily="34" charset="-122"/>
                 <a:cs typeface="Consolas" pitchFamily="34" charset="-120"/>
               </a:rPr>
-              <a:t>13 · RETOUR D'EXPÉRIENCE</a:t>
+              <a:t>13 · BILAN</a:t>
             </a:r>
             <a:endParaRPr lang="en-US" sz="1000" dirty="0"/>
           </a:p>
@@ -9160,7 +8634,7 @@
                 <a:ea typeface="Georgia" pitchFamily="34" charset="-122"/>
                 <a:cs typeface="Georgia" pitchFamily="34" charset="-120"/>
               </a:rPr>
-              <a:t>Les difficultés, et ce que j'en ai fait</a:t>
+              <a:t>Ce que j'en retiens, et la suite</a:t>
             </a:r>
             <a:endParaRPr lang="en-US" sz="3200" dirty="0"/>
           </a:p>
@@ -9199,7 +8673,7 @@
                 <a:ea typeface="Consolas" pitchFamily="34" charset="-122"/>
                 <a:cs typeface="Consolas" pitchFamily="34" charset="-120"/>
               </a:rPr>
-              <a:t>16 / 18</a:t>
+              <a:t>16 / 17</a:t>
             </a:r>
             <a:endParaRPr lang="en-US" sz="900" dirty="0"/>
           </a:p>
@@ -9246,92 +8720,14 @@
       </p:sp>
       <p:sp>
         <p:nvSpPr>
-          <p:cNvPr id="9" name="Text 6"/>
-          <p:cNvSpPr txBox="1"/>
-          <p:nvPr/>
-        </p:nvSpPr>
-        <p:spPr>
-          <a:xfrm>
-            <a:off x="548640" y="1664208"/>
-            <a:ext cx="3657600" cy="228600"/>
-          </a:xfrm>
-          <a:prstGeom prst="rect">
-            <a:avLst/>
-          </a:prstGeom>
-          <a:noFill/>
-          <a:ln/>
-        </p:spPr>
-        <p:txBody>
-          <a:bodyPr wrap="square" lIns="0" tIns="0" rIns="0" bIns="0" rtlCol="0" anchor="t"/>
-          <a:lstStyle/>
-          <a:p>
-            <a:pPr indent="0" marL="0">
-              <a:buNone/>
-            </a:pPr>
-            <a:r>
-              <a:rPr lang="en-US" sz="1000" b="1" spc="200" kern="0" dirty="0">
-                <a:solidFill>
-                  <a:srgbClr val="B23A2A"/>
-                </a:solidFill>
-                <a:latin typeface="Consolas" pitchFamily="34" charset="0"/>
-                <a:ea typeface="Consolas" pitchFamily="34" charset="-122"/>
-                <a:cs typeface="Consolas" pitchFamily="34" charset="-120"/>
-              </a:rPr>
-              <a:t>PROBLÈME</a:t>
-            </a:r>
-            <a:endParaRPr lang="en-US" sz="1000" dirty="0"/>
-          </a:p>
-        </p:txBody>
-      </p:sp>
-      <p:sp>
-        <p:nvSpPr>
-          <p:cNvPr id="10" name="Text 7"/>
-          <p:cNvSpPr txBox="1"/>
-          <p:nvPr/>
-        </p:nvSpPr>
-        <p:spPr>
-          <a:xfrm>
-            <a:off x="5074920" y="1664208"/>
-            <a:ext cx="3657600" cy="228600"/>
-          </a:xfrm>
-          <a:prstGeom prst="rect">
-            <a:avLst/>
-          </a:prstGeom>
-          <a:noFill/>
-          <a:ln/>
-        </p:spPr>
-        <p:txBody>
-          <a:bodyPr wrap="square" lIns="0" tIns="0" rIns="0" bIns="0" rtlCol="0" anchor="t"/>
-          <a:lstStyle/>
-          <a:p>
-            <a:pPr indent="0" marL="0">
-              <a:buNone/>
-            </a:pPr>
-            <a:r>
-              <a:rPr lang="en-US" sz="1000" b="1" spc="200" kern="0" dirty="0">
-                <a:solidFill>
-                  <a:srgbClr val="2E7250"/>
-                </a:solidFill>
-                <a:latin typeface="Consolas" pitchFamily="34" charset="0"/>
-                <a:ea typeface="Consolas" pitchFamily="34" charset="-122"/>
-                <a:cs typeface="Consolas" pitchFamily="34" charset="-120"/>
-              </a:rPr>
-              <a:t>SOLUTION</a:t>
-            </a:r>
-            <a:endParaRPr lang="en-US" sz="1000" dirty="0"/>
-          </a:p>
-        </p:txBody>
-      </p:sp>
-      <p:sp>
-        <p:nvSpPr>
-          <p:cNvPr id="11" name="Shape 8"/>
+          <p:cNvPr id="9" name="Shape 6"/>
           <p:cNvSpPr/>
           <p:nvPr/>
         </p:nvSpPr>
         <p:spPr>
           <a:xfrm>
-            <a:off x="548640" y="2011680"/>
-            <a:ext cx="11094415" cy="822960"/>
+            <a:off x="548640" y="1691640"/>
+            <a:ext cx="5394960" cy="4251960"/>
           </a:xfrm>
           <a:prstGeom prst="rect">
             <a:avLst/>
@@ -9356,30 +8752,30 @@
       </p:sp>
       <p:sp>
         <p:nvSpPr>
-          <p:cNvPr id="12" name="Text 9"/>
-          <p:cNvSpPr txBox="1"/>
-          <p:nvPr/>
-        </p:nvSpPr>
-        <p:spPr>
-          <a:xfrm>
-            <a:off x="822960" y="2011680"/>
-            <a:ext cx="3931920" cy="822960"/>
-          </a:xfrm>
-          <a:prstGeom prst="rect">
-            <a:avLst/>
-          </a:prstGeom>
-          <a:noFill/>
-          <a:ln/>
-        </p:spPr>
-        <p:txBody>
-          <a:bodyPr wrap="square" lIns="0" tIns="0" rIns="0" bIns="0" rtlCol="0" anchor="ctr"/>
-          <a:lstStyle/>
-          <a:p>
-            <a:pPr indent="0" marL="0">
-              <a:buNone/>
-            </a:pPr>
-            <a:r>
-              <a:rPr lang="en-US" sz="1550" dirty="0">
+          <p:cNvPr id="10" name="Text 7"/>
+          <p:cNvSpPr txBox="1"/>
+          <p:nvPr/>
+        </p:nvSpPr>
+        <p:spPr>
+          <a:xfrm>
+            <a:off x="868680" y="1920240"/>
+            <a:ext cx="4754880" cy="411480"/>
+          </a:xfrm>
+          <a:prstGeom prst="rect">
+            <a:avLst/>
+          </a:prstGeom>
+          <a:noFill/>
+          <a:ln/>
+        </p:spPr>
+        <p:txBody>
+          <a:bodyPr wrap="square" lIns="0" tIns="0" rIns="0" bIns="0" rtlCol="0" anchor="t"/>
+          <a:lstStyle/>
+          <a:p>
+            <a:pPr indent="0" marL="0">
+              <a:buNone/>
+            </a:pPr>
+            <a:r>
+              <a:rPr lang="en-US" sz="2200" dirty="0">
                 <a:solidFill>
                   <a:srgbClr val="17211C"/>
                 </a:solidFill>
@@ -9387,70 +8783,70 @@
                 <a:ea typeface="Georgia" pitchFamily="34" charset="-122"/>
                 <a:cs typeface="Georgia" pitchFamily="34" charset="-120"/>
               </a:rPr>
-              <a:t>Risque : contourner l'historique</a:t>
-            </a:r>
-            <a:endParaRPr lang="en-US" sz="1550" dirty="0"/>
-          </a:p>
-        </p:txBody>
-      </p:sp>
-      <p:sp>
-        <p:nvSpPr>
-          <p:cNvPr id="13" name="Text 10"/>
-          <p:cNvSpPr txBox="1"/>
-          <p:nvPr/>
-        </p:nvSpPr>
-        <p:spPr>
-          <a:xfrm>
-            <a:off x="4526280" y="2011680"/>
-            <a:ext cx="365760" cy="822960"/>
-          </a:xfrm>
-          <a:prstGeom prst="rect">
-            <a:avLst/>
-          </a:prstGeom>
-          <a:noFill/>
-          <a:ln/>
-        </p:spPr>
-        <p:txBody>
-          <a:bodyPr wrap="square" lIns="0" tIns="0" rIns="0" bIns="0" rtlCol="0" anchor="ctr"/>
-          <a:lstStyle/>
-          <a:p>
-            <a:pPr algn="ctr" indent="0" marL="0">
-              <a:buNone/>
-            </a:pPr>
-            <a:r>
-              <a:rPr lang="en-US" sz="1800" dirty="0">
-                <a:solidFill>
-                  <a:srgbClr val="767A71"/>
+              <a:t>Ce que j'ai appris</a:t>
+            </a:r>
+            <a:endParaRPr lang="en-US" sz="2200" dirty="0"/>
+          </a:p>
+        </p:txBody>
+      </p:sp>
+      <p:sp>
+        <p:nvSpPr>
+          <p:cNvPr id="11" name="Text 8"/>
+          <p:cNvSpPr txBox="1"/>
+          <p:nvPr/>
+        </p:nvSpPr>
+        <p:spPr>
+          <a:xfrm>
+            <a:off x="868680" y="2560320"/>
+            <a:ext cx="4754880" cy="292608"/>
+          </a:xfrm>
+          <a:prstGeom prst="rect">
+            <a:avLst/>
+          </a:prstGeom>
+          <a:noFill/>
+          <a:ln/>
+        </p:spPr>
+        <p:txBody>
+          <a:bodyPr wrap="square" lIns="0" tIns="0" rIns="0" bIns="0" rtlCol="0" anchor="t"/>
+          <a:lstStyle/>
+          <a:p>
+            <a:pPr indent="0" marL="0">
+              <a:buNone/>
+            </a:pPr>
+            <a:r>
+              <a:rPr lang="en-US" sz="1450" b="1" dirty="0">
+                <a:solidFill>
+                  <a:srgbClr val="17211C"/>
                 </a:solidFill>
                 <a:latin typeface="Calibri" pitchFamily="34" charset="0"/>
                 <a:ea typeface="Calibri" pitchFamily="34" charset="-122"/>
                 <a:cs typeface="Calibri" pitchFamily="34" charset="-120"/>
               </a:rPr>
-              <a:t>→</a:t>
-            </a:r>
-            <a:endParaRPr lang="en-US" sz="1800" dirty="0"/>
-          </a:p>
-        </p:txBody>
-      </p:sp>
-      <p:sp>
-        <p:nvSpPr>
-          <p:cNvPr id="14" name="Text 11"/>
-          <p:cNvSpPr txBox="1"/>
-          <p:nvPr/>
-        </p:nvSpPr>
-        <p:spPr>
-          <a:xfrm>
-            <a:off x="5074920" y="2011680"/>
-            <a:ext cx="6400800" cy="822960"/>
-          </a:xfrm>
-          <a:prstGeom prst="rect">
-            <a:avLst/>
-          </a:prstGeom>
-          <a:noFill/>
-          <a:ln/>
-        </p:spPr>
-        <p:txBody>
-          <a:bodyPr wrap="square" lIns="0" tIns="0" rIns="0" bIns="0" rtlCol="0" anchor="ctr"/>
+              <a:t>Modéliser avant de coder</a:t>
+            </a:r>
+            <a:endParaRPr lang="en-US" sz="1450" dirty="0"/>
+          </a:p>
+        </p:txBody>
+      </p:sp>
+      <p:sp>
+        <p:nvSpPr>
+          <p:cNvPr id="12" name="Text 9"/>
+          <p:cNvSpPr txBox="1"/>
+          <p:nvPr/>
+        </p:nvSpPr>
+        <p:spPr>
+          <a:xfrm>
+            <a:off x="868680" y="2880360"/>
+            <a:ext cx="4754880" cy="640080"/>
+          </a:xfrm>
+          <a:prstGeom prst="rect">
+            <a:avLst/>
+          </a:prstGeom>
+          <a:noFill/>
+          <a:ln/>
+        </p:spPr>
+        <p:txBody>
+          <a:bodyPr wrap="square" lIns="0" tIns="0" rIns="0" bIns="0" rtlCol="0" anchor="t"/>
           <a:lstStyle/>
           <a:p>
             <a:pPr indent="0" marL="0">
@@ -9465,7 +8861,7 @@
                 <a:ea typeface="Calibri" pitchFamily="34" charset="-122"/>
                 <a:cs typeface="Calibri" pitchFamily="34" charset="-120"/>
               </a:rPr>
-              <a:t>L'état et la direction ne sont pas dans le formulaire : ils ne changent que par une action, qui écrit toujours dans l'historique.</a:t>
+              <a:t>Le schéma du cycle de vie a donné les tables, puis les écrans.</a:t>
             </a:r>
             <a:endParaRPr lang="en-US" sz="1250" dirty="0"/>
           </a:p>
@@ -9473,133 +8869,348 @@
       </p:sp>
       <p:sp>
         <p:nvSpPr>
-          <p:cNvPr id="15" name="Shape 12"/>
+          <p:cNvPr id="13" name="Text 10"/>
+          <p:cNvSpPr txBox="1"/>
+          <p:nvPr/>
+        </p:nvSpPr>
+        <p:spPr>
+          <a:xfrm>
+            <a:off x="868680" y="3639312"/>
+            <a:ext cx="4754880" cy="292608"/>
+          </a:xfrm>
+          <a:prstGeom prst="rect">
+            <a:avLst/>
+          </a:prstGeom>
+          <a:noFill/>
+          <a:ln/>
+        </p:spPr>
+        <p:txBody>
+          <a:bodyPr wrap="square" lIns="0" tIns="0" rIns="0" bIns="0" rtlCol="0" anchor="t"/>
+          <a:lstStyle/>
+          <a:p>
+            <a:pPr indent="0" marL="0">
+              <a:buNone/>
+            </a:pPr>
+            <a:r>
+              <a:rPr lang="en-US" sz="1450" b="1" dirty="0">
+                <a:solidFill>
+                  <a:srgbClr val="17211C"/>
+                </a:solidFill>
+                <a:latin typeface="Calibri" pitchFamily="34" charset="0"/>
+                <a:ea typeface="Calibri" pitchFamily="34" charset="-122"/>
+                <a:cs typeface="Calibri" pitchFamily="34" charset="-120"/>
+              </a:rPr>
+              <a:t>Laisser la base protéger les données</a:t>
+            </a:r>
+            <a:endParaRPr lang="en-US" sz="1450" dirty="0"/>
+          </a:p>
+        </p:txBody>
+      </p:sp>
+      <p:sp>
+        <p:nvSpPr>
+          <p:cNvPr id="14" name="Text 11"/>
+          <p:cNvSpPr txBox="1"/>
+          <p:nvPr/>
+        </p:nvSpPr>
+        <p:spPr>
+          <a:xfrm>
+            <a:off x="868680" y="3959352"/>
+            <a:ext cx="4754880" cy="640080"/>
+          </a:xfrm>
+          <a:prstGeom prst="rect">
+            <a:avLst/>
+          </a:prstGeom>
+          <a:noFill/>
+          <a:ln/>
+        </p:spPr>
+        <p:txBody>
+          <a:bodyPr wrap="square" lIns="0" tIns="0" rIns="0" bIns="0" rtlCol="0" anchor="t"/>
+          <a:lstStyle/>
+          <a:p>
+            <a:pPr indent="0" marL="0">
+              <a:buNone/>
+            </a:pPr>
+            <a:r>
+              <a:rPr lang="en-US" sz="1250" dirty="0">
+                <a:solidFill>
+                  <a:srgbClr val="3F4842"/>
+                </a:solidFill>
+                <a:latin typeface="Calibri" pitchFamily="34" charset="0"/>
+                <a:ea typeface="Calibri" pitchFamily="34" charset="-122"/>
+                <a:cs typeface="Calibri" pitchFamily="34" charset="-120"/>
+              </a:rPr>
+              <a:t>Clés étrangères, unicité, transactions : les règles tiennent même si l'interface se trompe.</a:t>
+            </a:r>
+            <a:endParaRPr lang="en-US" sz="1250" dirty="0"/>
+          </a:p>
+        </p:txBody>
+      </p:sp>
+      <p:sp>
+        <p:nvSpPr>
+          <p:cNvPr id="15" name="Text 12"/>
+          <p:cNvSpPr txBox="1"/>
+          <p:nvPr/>
+        </p:nvSpPr>
+        <p:spPr>
+          <a:xfrm>
+            <a:off x="868680" y="4718304"/>
+            <a:ext cx="4754880" cy="292608"/>
+          </a:xfrm>
+          <a:prstGeom prst="rect">
+            <a:avLst/>
+          </a:prstGeom>
+          <a:noFill/>
+          <a:ln/>
+        </p:spPr>
+        <p:txBody>
+          <a:bodyPr wrap="square" lIns="0" tIns="0" rIns="0" bIns="0" rtlCol="0" anchor="t"/>
+          <a:lstStyle/>
+          <a:p>
+            <a:pPr indent="0" marL="0">
+              <a:buNone/>
+            </a:pPr>
+            <a:r>
+              <a:rPr lang="en-US" sz="1450" b="1" dirty="0">
+                <a:solidFill>
+                  <a:srgbClr val="17211C"/>
+                </a:solidFill>
+                <a:latin typeface="Calibri" pitchFamily="34" charset="0"/>
+                <a:ea typeface="Calibri" pitchFamily="34" charset="-122"/>
+                <a:cs typeface="Calibri" pitchFamily="34" charset="-120"/>
+              </a:rPr>
+              <a:t>Aller jusqu'à la mise en ligne</a:t>
+            </a:r>
+            <a:endParaRPr lang="en-US" sz="1450" dirty="0"/>
+          </a:p>
+        </p:txBody>
+      </p:sp>
+      <p:sp>
+        <p:nvSpPr>
+          <p:cNvPr id="16" name="Text 13"/>
+          <p:cNvSpPr txBox="1"/>
+          <p:nvPr/>
+        </p:nvSpPr>
+        <p:spPr>
+          <a:xfrm>
+            <a:off x="868680" y="5038344"/>
+            <a:ext cx="4754880" cy="640080"/>
+          </a:xfrm>
+          <a:prstGeom prst="rect">
+            <a:avLst/>
+          </a:prstGeom>
+          <a:noFill/>
+          <a:ln/>
+        </p:spPr>
+        <p:txBody>
+          <a:bodyPr wrap="square" lIns="0" tIns="0" rIns="0" bIns="0" rtlCol="0" anchor="t"/>
+          <a:lstStyle/>
+          <a:p>
+            <a:pPr indent="0" marL="0">
+              <a:buNone/>
+            </a:pPr>
+            <a:r>
+              <a:rPr lang="en-US" sz="1250" dirty="0">
+                <a:solidFill>
+                  <a:srgbClr val="3F4842"/>
+                </a:solidFill>
+                <a:latin typeface="Calibri" pitchFamily="34" charset="0"/>
+                <a:ea typeface="Calibri" pitchFamily="34" charset="-122"/>
+                <a:cs typeface="Calibri" pitchFamily="34" charset="-120"/>
+              </a:rPr>
+              <a:t>Hébergeur gratuit, configuration, sécurité : un projet fini, pas seulement « qui marche chez moi ».</a:t>
+            </a:r>
+            <a:endParaRPr lang="en-US" sz="1250" dirty="0"/>
+          </a:p>
+        </p:txBody>
+      </p:sp>
+      <p:sp>
+        <p:nvSpPr>
+          <p:cNvPr id="17" name="Text 14"/>
+          <p:cNvSpPr txBox="1"/>
+          <p:nvPr/>
+        </p:nvSpPr>
+        <p:spPr>
+          <a:xfrm>
+            <a:off x="6263640" y="1920240"/>
+            <a:ext cx="5379415" cy="411480"/>
+          </a:xfrm>
+          <a:prstGeom prst="rect">
+            <a:avLst/>
+          </a:prstGeom>
+          <a:noFill/>
+          <a:ln/>
+        </p:spPr>
+        <p:txBody>
+          <a:bodyPr wrap="square" lIns="0" tIns="0" rIns="0" bIns="0" rtlCol="0" anchor="t"/>
+          <a:lstStyle/>
+          <a:p>
+            <a:pPr indent="0" marL="0">
+              <a:buNone/>
+            </a:pPr>
+            <a:r>
+              <a:rPr lang="en-US" sz="2200" dirty="0">
+                <a:solidFill>
+                  <a:srgbClr val="17211C"/>
+                </a:solidFill>
+                <a:latin typeface="Georgia" pitchFamily="34" charset="0"/>
+                <a:ea typeface="Georgia" pitchFamily="34" charset="-122"/>
+                <a:cs typeface="Georgia" pitchFamily="34" charset="-120"/>
+              </a:rPr>
+              <a:t>Et ensuite ?</a:t>
+            </a:r>
+            <a:endParaRPr lang="en-US" sz="2200" dirty="0"/>
+          </a:p>
+        </p:txBody>
+      </p:sp>
+      <p:sp>
+        <p:nvSpPr>
+          <p:cNvPr id="18" name="Shape 15"/>
           <p:cNvSpPr/>
           <p:nvPr/>
         </p:nvSpPr>
         <p:spPr>
           <a:xfrm>
-            <a:off x="548640" y="2999232"/>
-            <a:ext cx="11094415" cy="822960"/>
-          </a:xfrm>
-          <a:prstGeom prst="rect">
-            <a:avLst/>
+            <a:off x="6263640" y="2578608"/>
+            <a:ext cx="566928" cy="274320"/>
+          </a:xfrm>
+          <a:prstGeom prst="roundRect">
+            <a:avLst>
+              <a:gd name="adj" fmla="val 16667"/>
+            </a:avLst>
           </a:prstGeom>
           <a:solidFill>
-            <a:srgbClr val="FBF9F4"/>
+            <a:srgbClr val="FFFDF7"/>
           </a:solidFill>
           <a:ln w="9525">
             <a:solidFill>
-              <a:srgbClr val="DCD5C6"/>
+              <a:srgbClr val="CBC2AD"/>
             </a:solidFill>
             <a:prstDash val="solid"/>
           </a:ln>
-          <a:effectLst>
-            <a:outerShdw sx="100000" sy="100000" kx="0" ky="0" algn="bl" rotWithShape="0" blurRad="76200" dist="19050" dir="5400000">
-              <a:srgbClr val="1A2E25">
-                <a:alpha val="8000"/>
-              </a:srgbClr>
-            </a:outerShdw>
-          </a:effectLst>
-        </p:spPr>
-      </p:sp>
-      <p:sp>
-        <p:nvSpPr>
-          <p:cNvPr id="16" name="Text 13"/>
-          <p:cNvSpPr txBox="1"/>
-          <p:nvPr/>
-        </p:nvSpPr>
-        <p:spPr>
-          <a:xfrm>
-            <a:off x="822960" y="2999232"/>
-            <a:ext cx="3931920" cy="822960"/>
-          </a:xfrm>
-          <a:prstGeom prst="rect">
-            <a:avLst/>
-          </a:prstGeom>
-          <a:noFill/>
-          <a:ln/>
-        </p:spPr>
-        <p:txBody>
-          <a:bodyPr wrap="square" lIns="0" tIns="0" rIns="0" bIns="0" rtlCol="0" anchor="ctr"/>
-          <a:lstStyle/>
-          <a:p>
-            <a:pPr indent="0" marL="0">
-              <a:buNone/>
-            </a:pPr>
-            <a:r>
-              <a:rPr lang="en-US" sz="1550" dirty="0">
+        </p:spPr>
+      </p:sp>
+      <p:sp>
+        <p:nvSpPr>
+          <p:cNvPr id="19" name="Shape 16"/>
+          <p:cNvSpPr/>
+          <p:nvPr/>
+        </p:nvSpPr>
+        <p:spPr>
+          <a:xfrm>
+            <a:off x="6355080" y="2683764"/>
+            <a:ext cx="64008" cy="64008"/>
+          </a:xfrm>
+          <a:prstGeom prst="ellipse">
+            <a:avLst/>
+          </a:prstGeom>
+          <a:solidFill>
+            <a:srgbClr val="F3EFE6"/>
+          </a:solidFill>
+          <a:ln w="9525">
+            <a:solidFill>
+              <a:srgbClr val="CBC2AD"/>
+            </a:solidFill>
+            <a:prstDash val="solid"/>
+          </a:ln>
+        </p:spPr>
+      </p:sp>
+      <p:sp>
+        <p:nvSpPr>
+          <p:cNvPr id="20" name="Text 17"/>
+          <p:cNvSpPr txBox="1"/>
+          <p:nvPr/>
+        </p:nvSpPr>
+        <p:spPr>
+          <a:xfrm>
+            <a:off x="6483096" y="2578608"/>
+            <a:ext cx="329184" cy="274320"/>
+          </a:xfrm>
+          <a:prstGeom prst="rect">
+            <a:avLst/>
+          </a:prstGeom>
+          <a:noFill/>
+          <a:ln/>
+        </p:spPr>
+        <p:txBody>
+          <a:bodyPr wrap="none" lIns="0" tIns="0" rIns="0" bIns="0" rtlCol="0" anchor="ctr"/>
+          <a:lstStyle/>
+          <a:p>
+            <a:pPr indent="0" marL="0">
+              <a:buNone/>
+            </a:pPr>
+            <a:r>
+              <a:rPr lang="en-US" sz="1000" spc="100" kern="0" dirty="0">
                 <a:solidFill>
                   <a:srgbClr val="17211C"/>
                 </a:solidFill>
-                <a:latin typeface="Georgia" pitchFamily="34" charset="0"/>
-                <a:ea typeface="Georgia" pitchFamily="34" charset="-122"/>
-                <a:cs typeface="Georgia" pitchFamily="34" charset="-120"/>
-              </a:rPr>
-              <a:t>Un matériel change pendant un transfert</a:t>
-            </a:r>
-            <a:endParaRPr lang="en-US" sz="1550" dirty="0"/>
-          </a:p>
-        </p:txBody>
-      </p:sp>
-      <p:sp>
-        <p:nvSpPr>
-          <p:cNvPr id="17" name="Text 14"/>
-          <p:cNvSpPr txBox="1"/>
-          <p:nvPr/>
-        </p:nvSpPr>
-        <p:spPr>
-          <a:xfrm>
-            <a:off x="4526280" y="2999232"/>
-            <a:ext cx="365760" cy="822960"/>
-          </a:xfrm>
-          <a:prstGeom prst="rect">
-            <a:avLst/>
-          </a:prstGeom>
-          <a:noFill/>
-          <a:ln/>
-        </p:spPr>
-        <p:txBody>
-          <a:bodyPr wrap="square" lIns="0" tIns="0" rIns="0" bIns="0" rtlCol="0" anchor="ctr"/>
-          <a:lstStyle/>
-          <a:p>
-            <a:pPr algn="ctr" indent="0" marL="0">
-              <a:buNone/>
-            </a:pPr>
-            <a:r>
-              <a:rPr lang="en-US" sz="1800" dirty="0">
-                <a:solidFill>
-                  <a:srgbClr val="767A71"/>
+                <a:latin typeface="Consolas" pitchFamily="34" charset="0"/>
+                <a:ea typeface="Consolas" pitchFamily="34" charset="-122"/>
+                <a:cs typeface="Consolas" pitchFamily="34" charset="-120"/>
+              </a:rPr>
+              <a:t>01</a:t>
+            </a:r>
+            <a:endParaRPr lang="en-US" sz="1000" dirty="0"/>
+          </a:p>
+        </p:txBody>
+      </p:sp>
+      <p:sp>
+        <p:nvSpPr>
+          <p:cNvPr id="21" name="Text 18"/>
+          <p:cNvSpPr txBox="1"/>
+          <p:nvPr/>
+        </p:nvSpPr>
+        <p:spPr>
+          <a:xfrm>
+            <a:off x="7040880" y="2560320"/>
+            <a:ext cx="4602175" cy="292608"/>
+          </a:xfrm>
+          <a:prstGeom prst="rect">
+            <a:avLst/>
+          </a:prstGeom>
+          <a:noFill/>
+          <a:ln/>
+        </p:spPr>
+        <p:txBody>
+          <a:bodyPr wrap="square" lIns="0" tIns="0" rIns="0" bIns="0" rtlCol="0" anchor="t"/>
+          <a:lstStyle/>
+          <a:p>
+            <a:pPr indent="0" marL="0">
+              <a:buNone/>
+            </a:pPr>
+            <a:r>
+              <a:rPr lang="en-US" sz="1450" b="1" dirty="0">
+                <a:solidFill>
+                  <a:srgbClr val="17211C"/>
                 </a:solidFill>
                 <a:latin typeface="Calibri" pitchFamily="34" charset="0"/>
                 <a:ea typeface="Calibri" pitchFamily="34" charset="-122"/>
                 <a:cs typeface="Calibri" pitchFamily="34" charset="-120"/>
               </a:rPr>
-              <a:t>→</a:t>
-            </a:r>
-            <a:endParaRPr lang="en-US" sz="1800" dirty="0"/>
-          </a:p>
-        </p:txBody>
-      </p:sp>
-      <p:sp>
-        <p:nvSpPr>
-          <p:cNvPr id="18" name="Text 15"/>
-          <p:cNvSpPr txBox="1"/>
-          <p:nvPr/>
-        </p:nvSpPr>
-        <p:spPr>
-          <a:xfrm>
-            <a:off x="5074920" y="2999232"/>
-            <a:ext cx="6400800" cy="822960"/>
-          </a:xfrm>
-          <a:prstGeom prst="rect">
-            <a:avLst/>
-          </a:prstGeom>
-          <a:noFill/>
-          <a:ln/>
-        </p:spPr>
-        <p:txBody>
-          <a:bodyPr wrap="square" lIns="0" tIns="0" rIns="0" bIns="0" rtlCol="0" anchor="ctr"/>
+              <a:t>Scanner avec le téléphone</a:t>
+            </a:r>
+            <a:endParaRPr lang="en-US" sz="1450" dirty="0"/>
+          </a:p>
+        </p:txBody>
+      </p:sp>
+      <p:sp>
+        <p:nvSpPr>
+          <p:cNvPr id="22" name="Text 19"/>
+          <p:cNvSpPr txBox="1"/>
+          <p:nvPr/>
+        </p:nvSpPr>
+        <p:spPr>
+          <a:xfrm>
+            <a:off x="7040880" y="2871216"/>
+            <a:ext cx="4602175" cy="457200"/>
+          </a:xfrm>
+          <a:prstGeom prst="rect">
+            <a:avLst/>
+          </a:prstGeom>
+          <a:noFill/>
+          <a:ln/>
+        </p:spPr>
+        <p:txBody>
+          <a:bodyPr wrap="square" lIns="0" tIns="0" rIns="0" bIns="0" rtlCol="0" anchor="t"/>
           <a:lstStyle/>
           <a:p>
             <a:pPr indent="0" marL="0">
@@ -9614,7 +9225,7 @@
                 <a:ea typeface="Calibri" pitchFamily="34" charset="-122"/>
                 <a:cs typeface="Calibri" pitchFamily="34" charset="-120"/>
               </a:rPr>
-              <a:t>À la dernière validation, on revérifie la direction et l'état ; si ça a bougé, la demande est annulée.</a:t>
+              <a:t>Lire le code-barres avec la caméra pendant l'inventaire annuel.</a:t>
             </a:r>
             <a:endParaRPr lang="en-US" sz="1250" dirty="0"/>
           </a:p>
@@ -9622,133 +9233,153 @@
       </p:sp>
       <p:sp>
         <p:nvSpPr>
-          <p:cNvPr id="19" name="Shape 16"/>
+          <p:cNvPr id="23" name="Shape 20"/>
           <p:cNvSpPr/>
           <p:nvPr/>
         </p:nvSpPr>
         <p:spPr>
           <a:xfrm>
-            <a:off x="548640" y="3986784"/>
-            <a:ext cx="11094415" cy="822960"/>
-          </a:xfrm>
-          <a:prstGeom prst="rect">
-            <a:avLst/>
+            <a:off x="6263640" y="3401568"/>
+            <a:ext cx="566928" cy="274320"/>
+          </a:xfrm>
+          <a:prstGeom prst="roundRect">
+            <a:avLst>
+              <a:gd name="adj" fmla="val 16667"/>
+            </a:avLst>
           </a:prstGeom>
           <a:solidFill>
-            <a:srgbClr val="FBF9F4"/>
+            <a:srgbClr val="FFFDF7"/>
           </a:solidFill>
           <a:ln w="9525">
             <a:solidFill>
-              <a:srgbClr val="DCD5C6"/>
+              <a:srgbClr val="CBC2AD"/>
             </a:solidFill>
             <a:prstDash val="solid"/>
           </a:ln>
-          <a:effectLst>
-            <a:outerShdw sx="100000" sy="100000" kx="0" ky="0" algn="bl" rotWithShape="0" blurRad="76200" dist="19050" dir="5400000">
-              <a:srgbClr val="1A2E25">
-                <a:alpha val="8000"/>
-              </a:srgbClr>
-            </a:outerShdw>
-          </a:effectLst>
-        </p:spPr>
-      </p:sp>
-      <p:sp>
-        <p:nvSpPr>
-          <p:cNvPr id="20" name="Text 17"/>
-          <p:cNvSpPr txBox="1"/>
-          <p:nvPr/>
-        </p:nvSpPr>
-        <p:spPr>
-          <a:xfrm>
-            <a:off x="822960" y="3986784"/>
-            <a:ext cx="3931920" cy="822960"/>
-          </a:xfrm>
-          <a:prstGeom prst="rect">
-            <a:avLst/>
-          </a:prstGeom>
-          <a:noFill/>
-          <a:ln/>
-        </p:spPr>
-        <p:txBody>
-          <a:bodyPr wrap="square" lIns="0" tIns="0" rIns="0" bIns="0" rtlCol="0" anchor="ctr"/>
-          <a:lstStyle/>
-          <a:p>
-            <a:pPr indent="0" marL="0">
-              <a:buNone/>
-            </a:pPr>
-            <a:r>
-              <a:rPr lang="en-US" sz="1550" dirty="0">
+        </p:spPr>
+      </p:sp>
+      <p:sp>
+        <p:nvSpPr>
+          <p:cNvPr id="24" name="Shape 21"/>
+          <p:cNvSpPr/>
+          <p:nvPr/>
+        </p:nvSpPr>
+        <p:spPr>
+          <a:xfrm>
+            <a:off x="6355080" y="3506724"/>
+            <a:ext cx="64008" cy="64008"/>
+          </a:xfrm>
+          <a:prstGeom prst="ellipse">
+            <a:avLst/>
+          </a:prstGeom>
+          <a:solidFill>
+            <a:srgbClr val="F3EFE6"/>
+          </a:solidFill>
+          <a:ln w="9525">
+            <a:solidFill>
+              <a:srgbClr val="CBC2AD"/>
+            </a:solidFill>
+            <a:prstDash val="solid"/>
+          </a:ln>
+        </p:spPr>
+      </p:sp>
+      <p:sp>
+        <p:nvSpPr>
+          <p:cNvPr id="25" name="Text 22"/>
+          <p:cNvSpPr txBox="1"/>
+          <p:nvPr/>
+        </p:nvSpPr>
+        <p:spPr>
+          <a:xfrm>
+            <a:off x="6483096" y="3401568"/>
+            <a:ext cx="329184" cy="274320"/>
+          </a:xfrm>
+          <a:prstGeom prst="rect">
+            <a:avLst/>
+          </a:prstGeom>
+          <a:noFill/>
+          <a:ln/>
+        </p:spPr>
+        <p:txBody>
+          <a:bodyPr wrap="none" lIns="0" tIns="0" rIns="0" bIns="0" rtlCol="0" anchor="ctr"/>
+          <a:lstStyle/>
+          <a:p>
+            <a:pPr indent="0" marL="0">
+              <a:buNone/>
+            </a:pPr>
+            <a:r>
+              <a:rPr lang="en-US" sz="1000" spc="100" kern="0" dirty="0">
                 <a:solidFill>
                   <a:srgbClr val="17211C"/>
                 </a:solidFill>
-                <a:latin typeface="Georgia" pitchFamily="34" charset="0"/>
-                <a:ea typeface="Georgia" pitchFamily="34" charset="-122"/>
-                <a:cs typeface="Georgia" pitchFamily="34" charset="-120"/>
-              </a:rPr>
-              <a:t>Requêtes refusées en MySQL strict</a:t>
-            </a:r>
-            <a:endParaRPr lang="en-US" sz="1550" dirty="0"/>
-          </a:p>
-        </p:txBody>
-      </p:sp>
-      <p:sp>
-        <p:nvSpPr>
-          <p:cNvPr id="21" name="Text 18"/>
-          <p:cNvSpPr txBox="1"/>
-          <p:nvPr/>
-        </p:nvSpPr>
-        <p:spPr>
-          <a:xfrm>
-            <a:off x="4526280" y="3986784"/>
-            <a:ext cx="365760" cy="822960"/>
-          </a:xfrm>
-          <a:prstGeom prst="rect">
-            <a:avLst/>
-          </a:prstGeom>
-          <a:noFill/>
-          <a:ln/>
-        </p:spPr>
-        <p:txBody>
-          <a:bodyPr wrap="square" lIns="0" tIns="0" rIns="0" bIns="0" rtlCol="0" anchor="ctr"/>
-          <a:lstStyle/>
-          <a:p>
-            <a:pPr algn="ctr" indent="0" marL="0">
-              <a:buNone/>
-            </a:pPr>
-            <a:r>
-              <a:rPr lang="en-US" sz="1800" dirty="0">
-                <a:solidFill>
-                  <a:srgbClr val="767A71"/>
+                <a:latin typeface="Consolas" pitchFamily="34" charset="0"/>
+                <a:ea typeface="Consolas" pitchFamily="34" charset="-122"/>
+                <a:cs typeface="Consolas" pitchFamily="34" charset="-120"/>
+              </a:rPr>
+              <a:t>02</a:t>
+            </a:r>
+            <a:endParaRPr lang="en-US" sz="1000" dirty="0"/>
+          </a:p>
+        </p:txBody>
+      </p:sp>
+      <p:sp>
+        <p:nvSpPr>
+          <p:cNvPr id="26" name="Text 23"/>
+          <p:cNvSpPr txBox="1"/>
+          <p:nvPr/>
+        </p:nvSpPr>
+        <p:spPr>
+          <a:xfrm>
+            <a:off x="7040880" y="3383280"/>
+            <a:ext cx="4602175" cy="292608"/>
+          </a:xfrm>
+          <a:prstGeom prst="rect">
+            <a:avLst/>
+          </a:prstGeom>
+          <a:noFill/>
+          <a:ln/>
+        </p:spPr>
+        <p:txBody>
+          <a:bodyPr wrap="square" lIns="0" tIns="0" rIns="0" bIns="0" rtlCol="0" anchor="t"/>
+          <a:lstStyle/>
+          <a:p>
+            <a:pPr indent="0" marL="0">
+              <a:buNone/>
+            </a:pPr>
+            <a:r>
+              <a:rPr lang="en-US" sz="1450" b="1" dirty="0">
+                <a:solidFill>
+                  <a:srgbClr val="17211C"/>
                 </a:solidFill>
                 <a:latin typeface="Calibri" pitchFamily="34" charset="0"/>
                 <a:ea typeface="Calibri" pitchFamily="34" charset="-122"/>
                 <a:cs typeface="Calibri" pitchFamily="34" charset="-120"/>
               </a:rPr>
-              <a:t>→</a:t>
-            </a:r>
-            <a:endParaRPr lang="en-US" sz="1800" dirty="0"/>
-          </a:p>
-        </p:txBody>
-      </p:sp>
-      <p:sp>
-        <p:nvSpPr>
-          <p:cNvPr id="22" name="Text 19"/>
-          <p:cNvSpPr txBox="1"/>
-          <p:nvPr/>
-        </p:nvSpPr>
-        <p:spPr>
-          <a:xfrm>
-            <a:off x="5074920" y="3986784"/>
-            <a:ext cx="6400800" cy="822960"/>
-          </a:xfrm>
-          <a:prstGeom prst="rect">
-            <a:avLst/>
-          </a:prstGeom>
-          <a:noFill/>
-          <a:ln/>
-        </p:spPr>
-        <p:txBody>
-          <a:bodyPr wrap="square" lIns="0" tIns="0" rIns="0" bIns="0" rtlCol="0" anchor="ctr"/>
+              <a:t>Pièces jointes</a:t>
+            </a:r>
+            <a:endParaRPr lang="en-US" sz="1450" dirty="0"/>
+          </a:p>
+        </p:txBody>
+      </p:sp>
+      <p:sp>
+        <p:nvSpPr>
+          <p:cNvPr id="27" name="Text 24"/>
+          <p:cNvSpPr txBox="1"/>
+          <p:nvPr/>
+        </p:nvSpPr>
+        <p:spPr>
+          <a:xfrm>
+            <a:off x="7040880" y="3694176"/>
+            <a:ext cx="4602175" cy="457200"/>
+          </a:xfrm>
+          <a:prstGeom prst="rect">
+            <a:avLst/>
+          </a:prstGeom>
+          <a:noFill/>
+          <a:ln/>
+        </p:spPr>
+        <p:txBody>
+          <a:bodyPr wrap="square" lIns="0" tIns="0" rIns="0" bIns="0" rtlCol="0" anchor="t"/>
           <a:lstStyle/>
           <a:p>
             <a:pPr indent="0" marL="0">
@@ -9763,7 +9394,7 @@
                 <a:ea typeface="Calibri" pitchFamily="34" charset="-122"/>
                 <a:cs typeface="Calibri" pitchFamily="34" charset="-120"/>
               </a:rPr>
-              <a:t>GROUP BY complété avec toutes les colonnes affichées : même résultat, compatible partout.</a:t>
+              <a:t>Joindre le PV de réforme ou la facture en PDF à la fiche.</a:t>
             </a:r>
             <a:endParaRPr lang="en-US" sz="1250" dirty="0"/>
           </a:p>
@@ -9771,133 +9402,153 @@
       </p:sp>
       <p:sp>
         <p:nvSpPr>
-          <p:cNvPr id="23" name="Shape 20"/>
+          <p:cNvPr id="28" name="Shape 25"/>
           <p:cNvSpPr/>
           <p:nvPr/>
         </p:nvSpPr>
         <p:spPr>
           <a:xfrm>
-            <a:off x="548640" y="4974336"/>
-            <a:ext cx="11094415" cy="822960"/>
-          </a:xfrm>
-          <a:prstGeom prst="rect">
-            <a:avLst/>
+            <a:off x="6263640" y="4224528"/>
+            <a:ext cx="566928" cy="274320"/>
+          </a:xfrm>
+          <a:prstGeom prst="roundRect">
+            <a:avLst>
+              <a:gd name="adj" fmla="val 16667"/>
+            </a:avLst>
           </a:prstGeom>
           <a:solidFill>
-            <a:srgbClr val="FBF9F4"/>
+            <a:srgbClr val="FFFDF7"/>
           </a:solidFill>
           <a:ln w="9525">
             <a:solidFill>
-              <a:srgbClr val="DCD5C6"/>
+              <a:srgbClr val="CBC2AD"/>
             </a:solidFill>
             <a:prstDash val="solid"/>
           </a:ln>
-          <a:effectLst>
-            <a:outerShdw sx="100000" sy="100000" kx="0" ky="0" algn="bl" rotWithShape="0" blurRad="76200" dist="19050" dir="5400000">
-              <a:srgbClr val="1A2E25">
-                <a:alpha val="8000"/>
-              </a:srgbClr>
-            </a:outerShdw>
-          </a:effectLst>
-        </p:spPr>
-      </p:sp>
-      <p:sp>
-        <p:nvSpPr>
-          <p:cNvPr id="24" name="Text 21"/>
-          <p:cNvSpPr txBox="1"/>
-          <p:nvPr/>
-        </p:nvSpPr>
-        <p:spPr>
-          <a:xfrm>
-            <a:off x="822960" y="4974336"/>
-            <a:ext cx="3931920" cy="822960"/>
-          </a:xfrm>
-          <a:prstGeom prst="rect">
-            <a:avLst/>
-          </a:prstGeom>
-          <a:noFill/>
-          <a:ln/>
-        </p:spPr>
-        <p:txBody>
-          <a:bodyPr wrap="square" lIns="0" tIns="0" rIns="0" bIns="0" rtlCol="0" anchor="ctr"/>
-          <a:lstStyle/>
-          <a:p>
-            <a:pPr indent="0" marL="0">
-              <a:buNone/>
-            </a:pPr>
-            <a:r>
-              <a:rPr lang="en-US" sz="1550" dirty="0">
+        </p:spPr>
+      </p:sp>
+      <p:sp>
+        <p:nvSpPr>
+          <p:cNvPr id="29" name="Shape 26"/>
+          <p:cNvSpPr/>
+          <p:nvPr/>
+        </p:nvSpPr>
+        <p:spPr>
+          <a:xfrm>
+            <a:off x="6355080" y="4329684"/>
+            <a:ext cx="64008" cy="64008"/>
+          </a:xfrm>
+          <a:prstGeom prst="ellipse">
+            <a:avLst/>
+          </a:prstGeom>
+          <a:solidFill>
+            <a:srgbClr val="F3EFE6"/>
+          </a:solidFill>
+          <a:ln w="9525">
+            <a:solidFill>
+              <a:srgbClr val="CBC2AD"/>
+            </a:solidFill>
+            <a:prstDash val="solid"/>
+          </a:ln>
+        </p:spPr>
+      </p:sp>
+      <p:sp>
+        <p:nvSpPr>
+          <p:cNvPr id="30" name="Text 27"/>
+          <p:cNvSpPr txBox="1"/>
+          <p:nvPr/>
+        </p:nvSpPr>
+        <p:spPr>
+          <a:xfrm>
+            <a:off x="6483096" y="4224528"/>
+            <a:ext cx="329184" cy="274320"/>
+          </a:xfrm>
+          <a:prstGeom prst="rect">
+            <a:avLst/>
+          </a:prstGeom>
+          <a:noFill/>
+          <a:ln/>
+        </p:spPr>
+        <p:txBody>
+          <a:bodyPr wrap="none" lIns="0" tIns="0" rIns="0" bIns="0" rtlCol="0" anchor="ctr"/>
+          <a:lstStyle/>
+          <a:p>
+            <a:pPr indent="0" marL="0">
+              <a:buNone/>
+            </a:pPr>
+            <a:r>
+              <a:rPr lang="en-US" sz="1000" spc="100" kern="0" dirty="0">
                 <a:solidFill>
                   <a:srgbClr val="17211C"/>
                 </a:solidFill>
-                <a:latin typeface="Georgia" pitchFamily="34" charset="0"/>
-                <a:ea typeface="Georgia" pitchFamily="34" charset="-122"/>
-                <a:cs typeface="Georgia" pitchFamily="34" charset="-120"/>
-              </a:rPr>
-              <a:t>Export CSV pollué (PHP 8.4)</a:t>
-            </a:r>
-            <a:endParaRPr lang="en-US" sz="1550" dirty="0"/>
-          </a:p>
-        </p:txBody>
-      </p:sp>
-      <p:sp>
-        <p:nvSpPr>
-          <p:cNvPr id="25" name="Text 22"/>
-          <p:cNvSpPr txBox="1"/>
-          <p:nvPr/>
-        </p:nvSpPr>
-        <p:spPr>
-          <a:xfrm>
-            <a:off x="4526280" y="4974336"/>
-            <a:ext cx="365760" cy="822960"/>
-          </a:xfrm>
-          <a:prstGeom prst="rect">
-            <a:avLst/>
-          </a:prstGeom>
-          <a:noFill/>
-          <a:ln/>
-        </p:spPr>
-        <p:txBody>
-          <a:bodyPr wrap="square" lIns="0" tIns="0" rIns="0" bIns="0" rtlCol="0" anchor="ctr"/>
-          <a:lstStyle/>
-          <a:p>
-            <a:pPr algn="ctr" indent="0" marL="0">
-              <a:buNone/>
-            </a:pPr>
-            <a:r>
-              <a:rPr lang="en-US" sz="1800" dirty="0">
-                <a:solidFill>
-                  <a:srgbClr val="767A71"/>
+                <a:latin typeface="Consolas" pitchFamily="34" charset="0"/>
+                <a:ea typeface="Consolas" pitchFamily="34" charset="-122"/>
+                <a:cs typeface="Consolas" pitchFamily="34" charset="-120"/>
+              </a:rPr>
+              <a:t>03</a:t>
+            </a:r>
+            <a:endParaRPr lang="en-US" sz="1000" dirty="0"/>
+          </a:p>
+        </p:txBody>
+      </p:sp>
+      <p:sp>
+        <p:nvSpPr>
+          <p:cNvPr id="31" name="Text 28"/>
+          <p:cNvSpPr txBox="1"/>
+          <p:nvPr/>
+        </p:nvSpPr>
+        <p:spPr>
+          <a:xfrm>
+            <a:off x="7040880" y="4206240"/>
+            <a:ext cx="4602175" cy="292608"/>
+          </a:xfrm>
+          <a:prstGeom prst="rect">
+            <a:avLst/>
+          </a:prstGeom>
+          <a:noFill/>
+          <a:ln/>
+        </p:spPr>
+        <p:txBody>
+          <a:bodyPr wrap="square" lIns="0" tIns="0" rIns="0" bIns="0" rtlCol="0" anchor="t"/>
+          <a:lstStyle/>
+          <a:p>
+            <a:pPr indent="0" marL="0">
+              <a:buNone/>
+            </a:pPr>
+            <a:r>
+              <a:rPr lang="en-US" sz="1450" b="1" dirty="0">
+                <a:solidFill>
+                  <a:srgbClr val="17211C"/>
                 </a:solidFill>
                 <a:latin typeface="Calibri" pitchFamily="34" charset="0"/>
                 <a:ea typeface="Calibri" pitchFamily="34" charset="-122"/>
                 <a:cs typeface="Calibri" pitchFamily="34" charset="-120"/>
               </a:rPr>
-              <a:t>→</a:t>
-            </a:r>
-            <a:endParaRPr lang="en-US" sz="1800" dirty="0"/>
-          </a:p>
-        </p:txBody>
-      </p:sp>
-      <p:sp>
-        <p:nvSpPr>
-          <p:cNvPr id="26" name="Text 23"/>
-          <p:cNvSpPr txBox="1"/>
-          <p:nvPr/>
-        </p:nvSpPr>
-        <p:spPr>
-          <a:xfrm>
-            <a:off x="5074920" y="4974336"/>
-            <a:ext cx="6400800" cy="822960"/>
-          </a:xfrm>
-          <a:prstGeom prst="rect">
-            <a:avLst/>
-          </a:prstGeom>
-          <a:noFill/>
-          <a:ln/>
-        </p:spPr>
-        <p:txBody>
-          <a:bodyPr wrap="square" lIns="0" tIns="0" rIns="0" bIns="0" rtlCol="0" anchor="ctr"/>
+              <a:t>Notifications</a:t>
+            </a:r>
+            <a:endParaRPr lang="en-US" sz="1450" dirty="0"/>
+          </a:p>
+        </p:txBody>
+      </p:sp>
+      <p:sp>
+        <p:nvSpPr>
+          <p:cNvPr id="32" name="Text 29"/>
+          <p:cNvSpPr txBox="1"/>
+          <p:nvPr/>
+        </p:nvSpPr>
+        <p:spPr>
+          <a:xfrm>
+            <a:off x="7040880" y="4517136"/>
+            <a:ext cx="4602175" cy="457200"/>
+          </a:xfrm>
+          <a:prstGeom prst="rect">
+            <a:avLst/>
+          </a:prstGeom>
+          <a:noFill/>
+          <a:ln/>
+        </p:spPr>
+        <p:txBody>
+          <a:bodyPr wrap="square" lIns="0" tIns="0" rIns="0" bIns="0" rtlCol="0" anchor="t"/>
           <a:lstStyle/>
           <a:p>
             <a:pPr indent="0" marL="0">
@@ -9912,7 +9563,176 @@
                 <a:ea typeface="Calibri" pitchFamily="34" charset="-122"/>
                 <a:cs typeface="Calibri" pitchFamily="34" charset="-120"/>
               </a:rPr>
-              <a:t>Paramètre d'échappement de fputcsv précisé explicitement ; export propre et lisible dans Excel.</a:t>
+              <a:t>Prévenir par e-mail le responsable qui doit valider un transfert.</a:t>
+            </a:r>
+            <a:endParaRPr lang="en-US" sz="1250" dirty="0"/>
+          </a:p>
+        </p:txBody>
+      </p:sp>
+      <p:sp>
+        <p:nvSpPr>
+          <p:cNvPr id="33" name="Shape 30"/>
+          <p:cNvSpPr/>
+          <p:nvPr/>
+        </p:nvSpPr>
+        <p:spPr>
+          <a:xfrm>
+            <a:off x="6263640" y="5047488"/>
+            <a:ext cx="566928" cy="274320"/>
+          </a:xfrm>
+          <a:prstGeom prst="roundRect">
+            <a:avLst>
+              <a:gd name="adj" fmla="val 16667"/>
+            </a:avLst>
+          </a:prstGeom>
+          <a:solidFill>
+            <a:srgbClr val="FFFDF7"/>
+          </a:solidFill>
+          <a:ln w="9525">
+            <a:solidFill>
+              <a:srgbClr val="CBC2AD"/>
+            </a:solidFill>
+            <a:prstDash val="solid"/>
+          </a:ln>
+        </p:spPr>
+      </p:sp>
+      <p:sp>
+        <p:nvSpPr>
+          <p:cNvPr id="34" name="Shape 31"/>
+          <p:cNvSpPr/>
+          <p:nvPr/>
+        </p:nvSpPr>
+        <p:spPr>
+          <a:xfrm>
+            <a:off x="6355080" y="5152644"/>
+            <a:ext cx="64008" cy="64008"/>
+          </a:xfrm>
+          <a:prstGeom prst="ellipse">
+            <a:avLst/>
+          </a:prstGeom>
+          <a:solidFill>
+            <a:srgbClr val="F3EFE6"/>
+          </a:solidFill>
+          <a:ln w="9525">
+            <a:solidFill>
+              <a:srgbClr val="CBC2AD"/>
+            </a:solidFill>
+            <a:prstDash val="solid"/>
+          </a:ln>
+        </p:spPr>
+      </p:sp>
+      <p:sp>
+        <p:nvSpPr>
+          <p:cNvPr id="35" name="Text 32"/>
+          <p:cNvSpPr txBox="1"/>
+          <p:nvPr/>
+        </p:nvSpPr>
+        <p:spPr>
+          <a:xfrm>
+            <a:off x="6483096" y="5047488"/>
+            <a:ext cx="329184" cy="274320"/>
+          </a:xfrm>
+          <a:prstGeom prst="rect">
+            <a:avLst/>
+          </a:prstGeom>
+          <a:noFill/>
+          <a:ln/>
+        </p:spPr>
+        <p:txBody>
+          <a:bodyPr wrap="none" lIns="0" tIns="0" rIns="0" bIns="0" rtlCol="0" anchor="ctr"/>
+          <a:lstStyle/>
+          <a:p>
+            <a:pPr indent="0" marL="0">
+              <a:buNone/>
+            </a:pPr>
+            <a:r>
+              <a:rPr lang="en-US" sz="1000" spc="100" kern="0" dirty="0">
+                <a:solidFill>
+                  <a:srgbClr val="17211C"/>
+                </a:solidFill>
+                <a:latin typeface="Consolas" pitchFamily="34" charset="0"/>
+                <a:ea typeface="Consolas" pitchFamily="34" charset="-122"/>
+                <a:cs typeface="Consolas" pitchFamily="34" charset="-120"/>
+              </a:rPr>
+              <a:t>04</a:t>
+            </a:r>
+            <a:endParaRPr lang="en-US" sz="1000" dirty="0"/>
+          </a:p>
+        </p:txBody>
+      </p:sp>
+      <p:sp>
+        <p:nvSpPr>
+          <p:cNvPr id="36" name="Text 33"/>
+          <p:cNvSpPr txBox="1"/>
+          <p:nvPr/>
+        </p:nvSpPr>
+        <p:spPr>
+          <a:xfrm>
+            <a:off x="7040880" y="5029200"/>
+            <a:ext cx="4602175" cy="292608"/>
+          </a:xfrm>
+          <a:prstGeom prst="rect">
+            <a:avLst/>
+          </a:prstGeom>
+          <a:noFill/>
+          <a:ln/>
+        </p:spPr>
+        <p:txBody>
+          <a:bodyPr wrap="square" lIns="0" tIns="0" rIns="0" bIns="0" rtlCol="0" anchor="t"/>
+          <a:lstStyle/>
+          <a:p>
+            <a:pPr indent="0" marL="0">
+              <a:buNone/>
+            </a:pPr>
+            <a:r>
+              <a:rPr lang="en-US" sz="1450" b="1" dirty="0">
+                <a:solidFill>
+                  <a:srgbClr val="17211C"/>
+                </a:solidFill>
+                <a:latin typeface="Calibri" pitchFamily="34" charset="0"/>
+                <a:ea typeface="Calibri" pitchFamily="34" charset="-122"/>
+                <a:cs typeface="Calibri" pitchFamily="34" charset="-120"/>
+              </a:rPr>
+              <a:t>Amortissement</a:t>
+            </a:r>
+            <a:endParaRPr lang="en-US" sz="1450" dirty="0"/>
+          </a:p>
+        </p:txBody>
+      </p:sp>
+      <p:sp>
+        <p:nvSpPr>
+          <p:cNvPr id="37" name="Text 34"/>
+          <p:cNvSpPr txBox="1"/>
+          <p:nvPr/>
+        </p:nvSpPr>
+        <p:spPr>
+          <a:xfrm>
+            <a:off x="7040880" y="5340096"/>
+            <a:ext cx="4602175" cy="457200"/>
+          </a:xfrm>
+          <a:prstGeom prst="rect">
+            <a:avLst/>
+          </a:prstGeom>
+          <a:noFill/>
+          <a:ln/>
+        </p:spPr>
+        <p:txBody>
+          <a:bodyPr wrap="square" lIns="0" tIns="0" rIns="0" bIns="0" rtlCol="0" anchor="t"/>
+          <a:lstStyle/>
+          <a:p>
+            <a:pPr indent="0" marL="0">
+              <a:buNone/>
+            </a:pPr>
+            <a:r>
+              <a:rPr lang="en-US" sz="1250" dirty="0">
+                <a:solidFill>
+                  <a:srgbClr val="3F4842"/>
+                </a:solidFill>
+                <a:latin typeface="Calibri" pitchFamily="34" charset="0"/>
+                <a:ea typeface="Calibri" pitchFamily="34" charset="-122"/>
+                <a:cs typeface="Calibri" pitchFamily="34" charset="-120"/>
+              </a:rPr>
+              <a:t>Valeur d'achat et durée de vie, pour le service comptable.</a:t>
             </a:r>
             <a:endParaRPr lang="en-US" sz="1250" dirty="0"/>
           </a:p>
@@ -9929,1266 +9749,6 @@
 <file path=ppt/slides/slide17.xml><?xml version="1.0" encoding="utf-8"?>
 <p:sld xmlns:a="http://schemas.openxmlformats.org/drawingml/2006/main" xmlns:r="http://schemas.openxmlformats.org/officeDocument/2006/relationships" xmlns:p="http://schemas.openxmlformats.org/presentationml/2006/main">
   <p:cSld name="Slide 17">
-    <p:bg>
-      <p:bgPr>
-        <a:solidFill>
-          <a:srgbClr val="F3EFE6"/>
-        </a:solidFill>
-      </p:bgPr>
-    </p:bg>
-    <p:spTree>
-      <p:nvGrpSpPr>
-        <p:cNvPr id="1" name=""/>
-        <p:cNvGrpSpPr/>
-        <p:nvPr/>
-      </p:nvGrpSpPr>
-      <p:grpSpPr>
-        <a:xfrm>
-          <a:off x="0" y="0"/>
-          <a:ext cx="0" cy="0"/>
-          <a:chOff x="0" y="0"/>
-          <a:chExt cx="0" cy="0"/>
-        </a:xfrm>
-      </p:grpSpPr>
-      <p:sp>
-        <p:nvSpPr>
-          <p:cNvPr id="2" name="Shape 0"/>
-          <p:cNvSpPr/>
-          <p:nvPr/>
-        </p:nvSpPr>
-        <p:spPr>
-          <a:xfrm>
-            <a:off x="548640" y="384048"/>
-            <a:ext cx="1298448" cy="274320"/>
-          </a:xfrm>
-          <a:prstGeom prst="roundRect">
-            <a:avLst>
-              <a:gd name="adj" fmla="val 16667"/>
-            </a:avLst>
-          </a:prstGeom>
-          <a:solidFill>
-            <a:srgbClr val="FFFDF7"/>
-          </a:solidFill>
-          <a:ln w="9525">
-            <a:solidFill>
-              <a:srgbClr val="CBC2AD"/>
-            </a:solidFill>
-            <a:prstDash val="solid"/>
-          </a:ln>
-        </p:spPr>
-      </p:sp>
-      <p:sp>
-        <p:nvSpPr>
-          <p:cNvPr id="3" name="Shape 1"/>
-          <p:cNvSpPr/>
-          <p:nvPr/>
-        </p:nvSpPr>
-        <p:spPr>
-          <a:xfrm>
-            <a:off x="640080" y="489204"/>
-            <a:ext cx="64008" cy="64008"/>
-          </a:xfrm>
-          <a:prstGeom prst="ellipse">
-            <a:avLst/>
-          </a:prstGeom>
-          <a:solidFill>
-            <a:srgbClr val="F3EFE6"/>
-          </a:solidFill>
-          <a:ln w="9525">
-            <a:solidFill>
-              <a:srgbClr val="CBC2AD"/>
-            </a:solidFill>
-            <a:prstDash val="solid"/>
-          </a:ln>
-        </p:spPr>
-      </p:sp>
-      <p:sp>
-        <p:nvSpPr>
-          <p:cNvPr id="4" name="Text 2"/>
-          <p:cNvSpPr txBox="1"/>
-          <p:nvPr/>
-        </p:nvSpPr>
-        <p:spPr>
-          <a:xfrm>
-            <a:off x="768096" y="384048"/>
-            <a:ext cx="1060704" cy="274320"/>
-          </a:xfrm>
-          <a:prstGeom prst="rect">
-            <a:avLst/>
-          </a:prstGeom>
-          <a:noFill/>
-          <a:ln/>
-        </p:spPr>
-        <p:txBody>
-          <a:bodyPr wrap="none" lIns="0" tIns="0" rIns="0" bIns="0" rtlCol="0" anchor="ctr"/>
-          <a:lstStyle/>
-          <a:p>
-            <a:pPr indent="0" marL="0">
-              <a:buNone/>
-            </a:pPr>
-            <a:r>
-              <a:rPr lang="en-US" sz="1000" spc="100" kern="0" dirty="0">
-                <a:solidFill>
-                  <a:srgbClr val="17211C"/>
-                </a:solidFill>
-                <a:latin typeface="Consolas" pitchFamily="34" charset="0"/>
-                <a:ea typeface="Consolas" pitchFamily="34" charset="-122"/>
-                <a:cs typeface="Consolas" pitchFamily="34" charset="-120"/>
-              </a:rPr>
-              <a:t>14 · BILAN</a:t>
-            </a:r>
-            <a:endParaRPr lang="en-US" sz="1000" dirty="0"/>
-          </a:p>
-        </p:txBody>
-      </p:sp>
-      <p:sp>
-        <p:nvSpPr>
-          <p:cNvPr id="5" name="Text 3"/>
-          <p:cNvSpPr txBox="1"/>
-          <p:nvPr/>
-        </p:nvSpPr>
-        <p:spPr>
-          <a:xfrm>
-            <a:off x="548640" y="786384"/>
-            <a:ext cx="11094415" cy="731520"/>
-          </a:xfrm>
-          <a:prstGeom prst="rect">
-            <a:avLst/>
-          </a:prstGeom>
-          <a:noFill/>
-          <a:ln/>
-        </p:spPr>
-        <p:txBody>
-          <a:bodyPr wrap="square" lIns="0" tIns="0" rIns="0" bIns="0" rtlCol="0" anchor="ctr"/>
-          <a:lstStyle/>
-          <a:p>
-            <a:pPr indent="0" marL="0">
-              <a:buNone/>
-            </a:pPr>
-            <a:r>
-              <a:rPr lang="en-US" sz="3200" dirty="0">
-                <a:solidFill>
-                  <a:srgbClr val="17211C"/>
-                </a:solidFill>
-                <a:latin typeface="Georgia" pitchFamily="34" charset="0"/>
-                <a:ea typeface="Georgia" pitchFamily="34" charset="-122"/>
-                <a:cs typeface="Georgia" pitchFamily="34" charset="-120"/>
-              </a:rPr>
-              <a:t>Ce que j'en retiens, et la suite</a:t>
-            </a:r>
-            <a:endParaRPr lang="en-US" sz="3200" dirty="0"/>
-          </a:p>
-        </p:txBody>
-      </p:sp>
-      <p:sp>
-        <p:nvSpPr>
-          <p:cNvPr id="7" name="Text 4"/>
-          <p:cNvSpPr txBox="1"/>
-          <p:nvPr/>
-        </p:nvSpPr>
-        <p:spPr>
-          <a:xfrm>
-            <a:off x="10545775" y="6473952"/>
-            <a:ext cx="1097280" cy="228600"/>
-          </a:xfrm>
-          <a:prstGeom prst="rect">
-            <a:avLst/>
-          </a:prstGeom>
-          <a:noFill/>
-          <a:ln/>
-        </p:spPr>
-        <p:txBody>
-          <a:bodyPr wrap="square" lIns="0" tIns="0" rIns="0" bIns="0" rtlCol="0" anchor="t"/>
-          <a:lstStyle/>
-          <a:p>
-            <a:pPr algn="r" indent="0" marL="0">
-              <a:buNone/>
-            </a:pPr>
-            <a:r>
-              <a:rPr lang="en-US" sz="900" dirty="0">
-                <a:solidFill>
-                  <a:srgbClr val="767A71"/>
-                </a:solidFill>
-                <a:latin typeface="Consolas" pitchFamily="34" charset="0"/>
-                <a:ea typeface="Consolas" pitchFamily="34" charset="-122"/>
-                <a:cs typeface="Consolas" pitchFamily="34" charset="-120"/>
-              </a:rPr>
-              <a:t>17 / 18</a:t>
-            </a:r>
-            <a:endParaRPr lang="en-US" sz="900" dirty="0"/>
-          </a:p>
-        </p:txBody>
-      </p:sp>
-      <p:sp>
-        <p:nvSpPr>
-          <p:cNvPr id="8" name="Text 5"/>
-          <p:cNvSpPr txBox="1"/>
-          <p:nvPr/>
-        </p:nvSpPr>
-        <p:spPr>
-          <a:xfrm>
-            <a:off x="548640" y="6473952"/>
-            <a:ext cx="1828800" cy="228600"/>
-          </a:xfrm>
-          <a:prstGeom prst="rect">
-            <a:avLst/>
-          </a:prstGeom>
-          <a:noFill/>
-          <a:ln/>
-        </p:spPr>
-        <p:txBody>
-          <a:bodyPr wrap="square" lIns="0" tIns="0" rIns="0" bIns="0" rtlCol="0" anchor="t"/>
-          <a:lstStyle/>
-          <a:p>
-            <a:pPr indent="0" marL="0">
-              <a:buNone/>
-            </a:pPr>
-            <a:r>
-              <a:rPr lang="en-US" sz="1000" i="1" dirty="0">
-                <a:solidFill>
-                  <a:srgbClr val="767A71"/>
-                </a:solidFill>
-                <a:latin typeface="Georgia" pitchFamily="34" charset="0"/>
-                <a:ea typeface="Georgia" pitchFamily="34" charset="-122"/>
-                <a:cs typeface="Georgia" pitchFamily="34" charset="-120"/>
-              </a:rPr>
-              <a:t>Patrimo</a:t>
-            </a:r>
-            <a:endParaRPr lang="en-US" sz="1000" dirty="0"/>
-          </a:p>
-        </p:txBody>
-      </p:sp>
-      <p:sp>
-        <p:nvSpPr>
-          <p:cNvPr id="9" name="Shape 6"/>
-          <p:cNvSpPr/>
-          <p:nvPr/>
-        </p:nvSpPr>
-        <p:spPr>
-          <a:xfrm>
-            <a:off x="548640" y="1691640"/>
-            <a:ext cx="5394960" cy="4251960"/>
-          </a:xfrm>
-          <a:prstGeom prst="rect">
-            <a:avLst/>
-          </a:prstGeom>
-          <a:solidFill>
-            <a:srgbClr val="FBF9F4"/>
-          </a:solidFill>
-          <a:ln w="9525">
-            <a:solidFill>
-              <a:srgbClr val="DCD5C6"/>
-            </a:solidFill>
-            <a:prstDash val="solid"/>
-          </a:ln>
-          <a:effectLst>
-            <a:outerShdw sx="100000" sy="100000" kx="0" ky="0" algn="bl" rotWithShape="0" blurRad="76200" dist="19050" dir="5400000">
-              <a:srgbClr val="1A2E25">
-                <a:alpha val="8000"/>
-              </a:srgbClr>
-            </a:outerShdw>
-          </a:effectLst>
-        </p:spPr>
-      </p:sp>
-      <p:sp>
-        <p:nvSpPr>
-          <p:cNvPr id="10" name="Text 7"/>
-          <p:cNvSpPr txBox="1"/>
-          <p:nvPr/>
-        </p:nvSpPr>
-        <p:spPr>
-          <a:xfrm>
-            <a:off x="868680" y="1920240"/>
-            <a:ext cx="4754880" cy="411480"/>
-          </a:xfrm>
-          <a:prstGeom prst="rect">
-            <a:avLst/>
-          </a:prstGeom>
-          <a:noFill/>
-          <a:ln/>
-        </p:spPr>
-        <p:txBody>
-          <a:bodyPr wrap="square" lIns="0" tIns="0" rIns="0" bIns="0" rtlCol="0" anchor="t"/>
-          <a:lstStyle/>
-          <a:p>
-            <a:pPr indent="0" marL="0">
-              <a:buNone/>
-            </a:pPr>
-            <a:r>
-              <a:rPr lang="en-US" sz="2200" dirty="0">
-                <a:solidFill>
-                  <a:srgbClr val="17211C"/>
-                </a:solidFill>
-                <a:latin typeface="Georgia" pitchFamily="34" charset="0"/>
-                <a:ea typeface="Georgia" pitchFamily="34" charset="-122"/>
-                <a:cs typeface="Georgia" pitchFamily="34" charset="-120"/>
-              </a:rPr>
-              <a:t>Ce que j'ai appris</a:t>
-            </a:r>
-            <a:endParaRPr lang="en-US" sz="2200" dirty="0"/>
-          </a:p>
-        </p:txBody>
-      </p:sp>
-      <p:sp>
-        <p:nvSpPr>
-          <p:cNvPr id="11" name="Text 8"/>
-          <p:cNvSpPr txBox="1"/>
-          <p:nvPr/>
-        </p:nvSpPr>
-        <p:spPr>
-          <a:xfrm>
-            <a:off x="868680" y="2560320"/>
-            <a:ext cx="4754880" cy="292608"/>
-          </a:xfrm>
-          <a:prstGeom prst="rect">
-            <a:avLst/>
-          </a:prstGeom>
-          <a:noFill/>
-          <a:ln/>
-        </p:spPr>
-        <p:txBody>
-          <a:bodyPr wrap="square" lIns="0" tIns="0" rIns="0" bIns="0" rtlCol="0" anchor="t"/>
-          <a:lstStyle/>
-          <a:p>
-            <a:pPr indent="0" marL="0">
-              <a:buNone/>
-            </a:pPr>
-            <a:r>
-              <a:rPr lang="en-US" sz="1450" b="1" dirty="0">
-                <a:solidFill>
-                  <a:srgbClr val="17211C"/>
-                </a:solidFill>
-                <a:latin typeface="Calibri" pitchFamily="34" charset="0"/>
-                <a:ea typeface="Calibri" pitchFamily="34" charset="-122"/>
-                <a:cs typeface="Calibri" pitchFamily="34" charset="-120"/>
-              </a:rPr>
-              <a:t>Modéliser avant de coder</a:t>
-            </a:r>
-            <a:endParaRPr lang="en-US" sz="1450" dirty="0"/>
-          </a:p>
-        </p:txBody>
-      </p:sp>
-      <p:sp>
-        <p:nvSpPr>
-          <p:cNvPr id="12" name="Text 9"/>
-          <p:cNvSpPr txBox="1"/>
-          <p:nvPr/>
-        </p:nvSpPr>
-        <p:spPr>
-          <a:xfrm>
-            <a:off x="868680" y="2880360"/>
-            <a:ext cx="4754880" cy="640080"/>
-          </a:xfrm>
-          <a:prstGeom prst="rect">
-            <a:avLst/>
-          </a:prstGeom>
-          <a:noFill/>
-          <a:ln/>
-        </p:spPr>
-        <p:txBody>
-          <a:bodyPr wrap="square" lIns="0" tIns="0" rIns="0" bIns="0" rtlCol="0" anchor="t"/>
-          <a:lstStyle/>
-          <a:p>
-            <a:pPr indent="0" marL="0">
-              <a:buNone/>
-            </a:pPr>
-            <a:r>
-              <a:rPr lang="en-US" sz="1250" dirty="0">
-                <a:solidFill>
-                  <a:srgbClr val="3F4842"/>
-                </a:solidFill>
-                <a:latin typeface="Calibri" pitchFamily="34" charset="0"/>
-                <a:ea typeface="Calibri" pitchFamily="34" charset="-122"/>
-                <a:cs typeface="Calibri" pitchFamily="34" charset="-120"/>
-              </a:rPr>
-              <a:t>Le schéma du cycle de vie a donné les tables, puis les écrans.</a:t>
-            </a:r>
-            <a:endParaRPr lang="en-US" sz="1250" dirty="0"/>
-          </a:p>
-        </p:txBody>
-      </p:sp>
-      <p:sp>
-        <p:nvSpPr>
-          <p:cNvPr id="13" name="Text 10"/>
-          <p:cNvSpPr txBox="1"/>
-          <p:nvPr/>
-        </p:nvSpPr>
-        <p:spPr>
-          <a:xfrm>
-            <a:off x="868680" y="3639312"/>
-            <a:ext cx="4754880" cy="292608"/>
-          </a:xfrm>
-          <a:prstGeom prst="rect">
-            <a:avLst/>
-          </a:prstGeom>
-          <a:noFill/>
-          <a:ln/>
-        </p:spPr>
-        <p:txBody>
-          <a:bodyPr wrap="square" lIns="0" tIns="0" rIns="0" bIns="0" rtlCol="0" anchor="t"/>
-          <a:lstStyle/>
-          <a:p>
-            <a:pPr indent="0" marL="0">
-              <a:buNone/>
-            </a:pPr>
-            <a:r>
-              <a:rPr lang="en-US" sz="1450" b="1" dirty="0">
-                <a:solidFill>
-                  <a:srgbClr val="17211C"/>
-                </a:solidFill>
-                <a:latin typeface="Calibri" pitchFamily="34" charset="0"/>
-                <a:ea typeface="Calibri" pitchFamily="34" charset="-122"/>
-                <a:cs typeface="Calibri" pitchFamily="34" charset="-120"/>
-              </a:rPr>
-              <a:t>Laisser la base protéger les données</a:t>
-            </a:r>
-            <a:endParaRPr lang="en-US" sz="1450" dirty="0"/>
-          </a:p>
-        </p:txBody>
-      </p:sp>
-      <p:sp>
-        <p:nvSpPr>
-          <p:cNvPr id="14" name="Text 11"/>
-          <p:cNvSpPr txBox="1"/>
-          <p:nvPr/>
-        </p:nvSpPr>
-        <p:spPr>
-          <a:xfrm>
-            <a:off x="868680" y="3959352"/>
-            <a:ext cx="4754880" cy="640080"/>
-          </a:xfrm>
-          <a:prstGeom prst="rect">
-            <a:avLst/>
-          </a:prstGeom>
-          <a:noFill/>
-          <a:ln/>
-        </p:spPr>
-        <p:txBody>
-          <a:bodyPr wrap="square" lIns="0" tIns="0" rIns="0" bIns="0" rtlCol="0" anchor="t"/>
-          <a:lstStyle/>
-          <a:p>
-            <a:pPr indent="0" marL="0">
-              <a:buNone/>
-            </a:pPr>
-            <a:r>
-              <a:rPr lang="en-US" sz="1250" dirty="0">
-                <a:solidFill>
-                  <a:srgbClr val="3F4842"/>
-                </a:solidFill>
-                <a:latin typeface="Calibri" pitchFamily="34" charset="0"/>
-                <a:ea typeface="Calibri" pitchFamily="34" charset="-122"/>
-                <a:cs typeface="Calibri" pitchFamily="34" charset="-120"/>
-              </a:rPr>
-              <a:t>Clés étrangères, unicité, transactions : les règles tiennent même si l'interface se trompe.</a:t>
-            </a:r>
-            <a:endParaRPr lang="en-US" sz="1250" dirty="0"/>
-          </a:p>
-        </p:txBody>
-      </p:sp>
-      <p:sp>
-        <p:nvSpPr>
-          <p:cNvPr id="15" name="Text 12"/>
-          <p:cNvSpPr txBox="1"/>
-          <p:nvPr/>
-        </p:nvSpPr>
-        <p:spPr>
-          <a:xfrm>
-            <a:off x="868680" y="4718304"/>
-            <a:ext cx="4754880" cy="292608"/>
-          </a:xfrm>
-          <a:prstGeom prst="rect">
-            <a:avLst/>
-          </a:prstGeom>
-          <a:noFill/>
-          <a:ln/>
-        </p:spPr>
-        <p:txBody>
-          <a:bodyPr wrap="square" lIns="0" tIns="0" rIns="0" bIns="0" rtlCol="0" anchor="t"/>
-          <a:lstStyle/>
-          <a:p>
-            <a:pPr indent="0" marL="0">
-              <a:buNone/>
-            </a:pPr>
-            <a:r>
-              <a:rPr lang="en-US" sz="1450" b="1" dirty="0">
-                <a:solidFill>
-                  <a:srgbClr val="17211C"/>
-                </a:solidFill>
-                <a:latin typeface="Calibri" pitchFamily="34" charset="0"/>
-                <a:ea typeface="Calibri" pitchFamily="34" charset="-122"/>
-                <a:cs typeface="Calibri" pitchFamily="34" charset="-120"/>
-              </a:rPr>
-              <a:t>Aller jusqu'à la mise en ligne</a:t>
-            </a:r>
-            <a:endParaRPr lang="en-US" sz="1450" dirty="0"/>
-          </a:p>
-        </p:txBody>
-      </p:sp>
-      <p:sp>
-        <p:nvSpPr>
-          <p:cNvPr id="16" name="Text 13"/>
-          <p:cNvSpPr txBox="1"/>
-          <p:nvPr/>
-        </p:nvSpPr>
-        <p:spPr>
-          <a:xfrm>
-            <a:off x="868680" y="5038344"/>
-            <a:ext cx="4754880" cy="640080"/>
-          </a:xfrm>
-          <a:prstGeom prst="rect">
-            <a:avLst/>
-          </a:prstGeom>
-          <a:noFill/>
-          <a:ln/>
-        </p:spPr>
-        <p:txBody>
-          <a:bodyPr wrap="square" lIns="0" tIns="0" rIns="0" bIns="0" rtlCol="0" anchor="t"/>
-          <a:lstStyle/>
-          <a:p>
-            <a:pPr indent="0" marL="0">
-              <a:buNone/>
-            </a:pPr>
-            <a:r>
-              <a:rPr lang="en-US" sz="1250" dirty="0">
-                <a:solidFill>
-                  <a:srgbClr val="3F4842"/>
-                </a:solidFill>
-                <a:latin typeface="Calibri" pitchFamily="34" charset="0"/>
-                <a:ea typeface="Calibri" pitchFamily="34" charset="-122"/>
-                <a:cs typeface="Calibri" pitchFamily="34" charset="-120"/>
-              </a:rPr>
-              <a:t>Hébergeur gratuit, configuration, sécurité : un projet fini, pas seulement « qui marche chez moi ».</a:t>
-            </a:r>
-            <a:endParaRPr lang="en-US" sz="1250" dirty="0"/>
-          </a:p>
-        </p:txBody>
-      </p:sp>
-      <p:sp>
-        <p:nvSpPr>
-          <p:cNvPr id="17" name="Text 14"/>
-          <p:cNvSpPr txBox="1"/>
-          <p:nvPr/>
-        </p:nvSpPr>
-        <p:spPr>
-          <a:xfrm>
-            <a:off x="6263640" y="1920240"/>
-            <a:ext cx="5379415" cy="411480"/>
-          </a:xfrm>
-          <a:prstGeom prst="rect">
-            <a:avLst/>
-          </a:prstGeom>
-          <a:noFill/>
-          <a:ln/>
-        </p:spPr>
-        <p:txBody>
-          <a:bodyPr wrap="square" lIns="0" tIns="0" rIns="0" bIns="0" rtlCol="0" anchor="t"/>
-          <a:lstStyle/>
-          <a:p>
-            <a:pPr indent="0" marL="0">
-              <a:buNone/>
-            </a:pPr>
-            <a:r>
-              <a:rPr lang="en-US" sz="2200" dirty="0">
-                <a:solidFill>
-                  <a:srgbClr val="17211C"/>
-                </a:solidFill>
-                <a:latin typeface="Georgia" pitchFamily="34" charset="0"/>
-                <a:ea typeface="Georgia" pitchFamily="34" charset="-122"/>
-                <a:cs typeface="Georgia" pitchFamily="34" charset="-120"/>
-              </a:rPr>
-              <a:t>Et ensuite ?</a:t>
-            </a:r>
-            <a:endParaRPr lang="en-US" sz="2200" dirty="0"/>
-          </a:p>
-        </p:txBody>
-      </p:sp>
-      <p:sp>
-        <p:nvSpPr>
-          <p:cNvPr id="18" name="Shape 15"/>
-          <p:cNvSpPr/>
-          <p:nvPr/>
-        </p:nvSpPr>
-        <p:spPr>
-          <a:xfrm>
-            <a:off x="6263640" y="2578608"/>
-            <a:ext cx="566928" cy="274320"/>
-          </a:xfrm>
-          <a:prstGeom prst="roundRect">
-            <a:avLst>
-              <a:gd name="adj" fmla="val 16667"/>
-            </a:avLst>
-          </a:prstGeom>
-          <a:solidFill>
-            <a:srgbClr val="FFFDF7"/>
-          </a:solidFill>
-          <a:ln w="9525">
-            <a:solidFill>
-              <a:srgbClr val="CBC2AD"/>
-            </a:solidFill>
-            <a:prstDash val="solid"/>
-          </a:ln>
-        </p:spPr>
-      </p:sp>
-      <p:sp>
-        <p:nvSpPr>
-          <p:cNvPr id="19" name="Shape 16"/>
-          <p:cNvSpPr/>
-          <p:nvPr/>
-        </p:nvSpPr>
-        <p:spPr>
-          <a:xfrm>
-            <a:off x="6355080" y="2683764"/>
-            <a:ext cx="64008" cy="64008"/>
-          </a:xfrm>
-          <a:prstGeom prst="ellipse">
-            <a:avLst/>
-          </a:prstGeom>
-          <a:solidFill>
-            <a:srgbClr val="F3EFE6"/>
-          </a:solidFill>
-          <a:ln w="9525">
-            <a:solidFill>
-              <a:srgbClr val="CBC2AD"/>
-            </a:solidFill>
-            <a:prstDash val="solid"/>
-          </a:ln>
-        </p:spPr>
-      </p:sp>
-      <p:sp>
-        <p:nvSpPr>
-          <p:cNvPr id="20" name="Text 17"/>
-          <p:cNvSpPr txBox="1"/>
-          <p:nvPr/>
-        </p:nvSpPr>
-        <p:spPr>
-          <a:xfrm>
-            <a:off x="6483096" y="2578608"/>
-            <a:ext cx="329184" cy="274320"/>
-          </a:xfrm>
-          <a:prstGeom prst="rect">
-            <a:avLst/>
-          </a:prstGeom>
-          <a:noFill/>
-          <a:ln/>
-        </p:spPr>
-        <p:txBody>
-          <a:bodyPr wrap="none" lIns="0" tIns="0" rIns="0" bIns="0" rtlCol="0" anchor="ctr"/>
-          <a:lstStyle/>
-          <a:p>
-            <a:pPr indent="0" marL="0">
-              <a:buNone/>
-            </a:pPr>
-            <a:r>
-              <a:rPr lang="en-US" sz="1000" spc="100" kern="0" dirty="0">
-                <a:solidFill>
-                  <a:srgbClr val="17211C"/>
-                </a:solidFill>
-                <a:latin typeface="Consolas" pitchFamily="34" charset="0"/>
-                <a:ea typeface="Consolas" pitchFamily="34" charset="-122"/>
-                <a:cs typeface="Consolas" pitchFamily="34" charset="-120"/>
-              </a:rPr>
-              <a:t>01</a:t>
-            </a:r>
-            <a:endParaRPr lang="en-US" sz="1000" dirty="0"/>
-          </a:p>
-        </p:txBody>
-      </p:sp>
-      <p:sp>
-        <p:nvSpPr>
-          <p:cNvPr id="21" name="Text 18"/>
-          <p:cNvSpPr txBox="1"/>
-          <p:nvPr/>
-        </p:nvSpPr>
-        <p:spPr>
-          <a:xfrm>
-            <a:off x="7040880" y="2560320"/>
-            <a:ext cx="4602175" cy="292608"/>
-          </a:xfrm>
-          <a:prstGeom prst="rect">
-            <a:avLst/>
-          </a:prstGeom>
-          <a:noFill/>
-          <a:ln/>
-        </p:spPr>
-        <p:txBody>
-          <a:bodyPr wrap="square" lIns="0" tIns="0" rIns="0" bIns="0" rtlCol="0" anchor="t"/>
-          <a:lstStyle/>
-          <a:p>
-            <a:pPr indent="0" marL="0">
-              <a:buNone/>
-            </a:pPr>
-            <a:r>
-              <a:rPr lang="en-US" sz="1450" b="1" dirty="0">
-                <a:solidFill>
-                  <a:srgbClr val="17211C"/>
-                </a:solidFill>
-                <a:latin typeface="Calibri" pitchFamily="34" charset="0"/>
-                <a:ea typeface="Calibri" pitchFamily="34" charset="-122"/>
-                <a:cs typeface="Calibri" pitchFamily="34" charset="-120"/>
-              </a:rPr>
-              <a:t>Scanner avec le téléphone</a:t>
-            </a:r>
-            <a:endParaRPr lang="en-US" sz="1450" dirty="0"/>
-          </a:p>
-        </p:txBody>
-      </p:sp>
-      <p:sp>
-        <p:nvSpPr>
-          <p:cNvPr id="22" name="Text 19"/>
-          <p:cNvSpPr txBox="1"/>
-          <p:nvPr/>
-        </p:nvSpPr>
-        <p:spPr>
-          <a:xfrm>
-            <a:off x="7040880" y="2871216"/>
-            <a:ext cx="4602175" cy="457200"/>
-          </a:xfrm>
-          <a:prstGeom prst="rect">
-            <a:avLst/>
-          </a:prstGeom>
-          <a:noFill/>
-          <a:ln/>
-        </p:spPr>
-        <p:txBody>
-          <a:bodyPr wrap="square" lIns="0" tIns="0" rIns="0" bIns="0" rtlCol="0" anchor="t"/>
-          <a:lstStyle/>
-          <a:p>
-            <a:pPr indent="0" marL="0">
-              <a:buNone/>
-            </a:pPr>
-            <a:r>
-              <a:rPr lang="en-US" sz="1250" dirty="0">
-                <a:solidFill>
-                  <a:srgbClr val="3F4842"/>
-                </a:solidFill>
-                <a:latin typeface="Calibri" pitchFamily="34" charset="0"/>
-                <a:ea typeface="Calibri" pitchFamily="34" charset="-122"/>
-                <a:cs typeface="Calibri" pitchFamily="34" charset="-120"/>
-              </a:rPr>
-              <a:t>Lire le code-barres avec la caméra pendant l'inventaire annuel.</a:t>
-            </a:r>
-            <a:endParaRPr lang="en-US" sz="1250" dirty="0"/>
-          </a:p>
-        </p:txBody>
-      </p:sp>
-      <p:sp>
-        <p:nvSpPr>
-          <p:cNvPr id="23" name="Shape 20"/>
-          <p:cNvSpPr/>
-          <p:nvPr/>
-        </p:nvSpPr>
-        <p:spPr>
-          <a:xfrm>
-            <a:off x="6263640" y="3401568"/>
-            <a:ext cx="566928" cy="274320"/>
-          </a:xfrm>
-          <a:prstGeom prst="roundRect">
-            <a:avLst>
-              <a:gd name="adj" fmla="val 16667"/>
-            </a:avLst>
-          </a:prstGeom>
-          <a:solidFill>
-            <a:srgbClr val="FFFDF7"/>
-          </a:solidFill>
-          <a:ln w="9525">
-            <a:solidFill>
-              <a:srgbClr val="CBC2AD"/>
-            </a:solidFill>
-            <a:prstDash val="solid"/>
-          </a:ln>
-        </p:spPr>
-      </p:sp>
-      <p:sp>
-        <p:nvSpPr>
-          <p:cNvPr id="24" name="Shape 21"/>
-          <p:cNvSpPr/>
-          <p:nvPr/>
-        </p:nvSpPr>
-        <p:spPr>
-          <a:xfrm>
-            <a:off x="6355080" y="3506724"/>
-            <a:ext cx="64008" cy="64008"/>
-          </a:xfrm>
-          <a:prstGeom prst="ellipse">
-            <a:avLst/>
-          </a:prstGeom>
-          <a:solidFill>
-            <a:srgbClr val="F3EFE6"/>
-          </a:solidFill>
-          <a:ln w="9525">
-            <a:solidFill>
-              <a:srgbClr val="CBC2AD"/>
-            </a:solidFill>
-            <a:prstDash val="solid"/>
-          </a:ln>
-        </p:spPr>
-      </p:sp>
-      <p:sp>
-        <p:nvSpPr>
-          <p:cNvPr id="25" name="Text 22"/>
-          <p:cNvSpPr txBox="1"/>
-          <p:nvPr/>
-        </p:nvSpPr>
-        <p:spPr>
-          <a:xfrm>
-            <a:off x="6483096" y="3401568"/>
-            <a:ext cx="329184" cy="274320"/>
-          </a:xfrm>
-          <a:prstGeom prst="rect">
-            <a:avLst/>
-          </a:prstGeom>
-          <a:noFill/>
-          <a:ln/>
-        </p:spPr>
-        <p:txBody>
-          <a:bodyPr wrap="none" lIns="0" tIns="0" rIns="0" bIns="0" rtlCol="0" anchor="ctr"/>
-          <a:lstStyle/>
-          <a:p>
-            <a:pPr indent="0" marL="0">
-              <a:buNone/>
-            </a:pPr>
-            <a:r>
-              <a:rPr lang="en-US" sz="1000" spc="100" kern="0" dirty="0">
-                <a:solidFill>
-                  <a:srgbClr val="17211C"/>
-                </a:solidFill>
-                <a:latin typeface="Consolas" pitchFamily="34" charset="0"/>
-                <a:ea typeface="Consolas" pitchFamily="34" charset="-122"/>
-                <a:cs typeface="Consolas" pitchFamily="34" charset="-120"/>
-              </a:rPr>
-              <a:t>02</a:t>
-            </a:r>
-            <a:endParaRPr lang="en-US" sz="1000" dirty="0"/>
-          </a:p>
-        </p:txBody>
-      </p:sp>
-      <p:sp>
-        <p:nvSpPr>
-          <p:cNvPr id="26" name="Text 23"/>
-          <p:cNvSpPr txBox="1"/>
-          <p:nvPr/>
-        </p:nvSpPr>
-        <p:spPr>
-          <a:xfrm>
-            <a:off x="7040880" y="3383280"/>
-            <a:ext cx="4602175" cy="292608"/>
-          </a:xfrm>
-          <a:prstGeom prst="rect">
-            <a:avLst/>
-          </a:prstGeom>
-          <a:noFill/>
-          <a:ln/>
-        </p:spPr>
-        <p:txBody>
-          <a:bodyPr wrap="square" lIns="0" tIns="0" rIns="0" bIns="0" rtlCol="0" anchor="t"/>
-          <a:lstStyle/>
-          <a:p>
-            <a:pPr indent="0" marL="0">
-              <a:buNone/>
-            </a:pPr>
-            <a:r>
-              <a:rPr lang="en-US" sz="1450" b="1" dirty="0">
-                <a:solidFill>
-                  <a:srgbClr val="17211C"/>
-                </a:solidFill>
-                <a:latin typeface="Calibri" pitchFamily="34" charset="0"/>
-                <a:ea typeface="Calibri" pitchFamily="34" charset="-122"/>
-                <a:cs typeface="Calibri" pitchFamily="34" charset="-120"/>
-              </a:rPr>
-              <a:t>Pièces jointes</a:t>
-            </a:r>
-            <a:endParaRPr lang="en-US" sz="1450" dirty="0"/>
-          </a:p>
-        </p:txBody>
-      </p:sp>
-      <p:sp>
-        <p:nvSpPr>
-          <p:cNvPr id="27" name="Text 24"/>
-          <p:cNvSpPr txBox="1"/>
-          <p:nvPr/>
-        </p:nvSpPr>
-        <p:spPr>
-          <a:xfrm>
-            <a:off x="7040880" y="3694176"/>
-            <a:ext cx="4602175" cy="457200"/>
-          </a:xfrm>
-          <a:prstGeom prst="rect">
-            <a:avLst/>
-          </a:prstGeom>
-          <a:noFill/>
-          <a:ln/>
-        </p:spPr>
-        <p:txBody>
-          <a:bodyPr wrap="square" lIns="0" tIns="0" rIns="0" bIns="0" rtlCol="0" anchor="t"/>
-          <a:lstStyle/>
-          <a:p>
-            <a:pPr indent="0" marL="0">
-              <a:buNone/>
-            </a:pPr>
-            <a:r>
-              <a:rPr lang="en-US" sz="1250" dirty="0">
-                <a:solidFill>
-                  <a:srgbClr val="3F4842"/>
-                </a:solidFill>
-                <a:latin typeface="Calibri" pitchFamily="34" charset="0"/>
-                <a:ea typeface="Calibri" pitchFamily="34" charset="-122"/>
-                <a:cs typeface="Calibri" pitchFamily="34" charset="-120"/>
-              </a:rPr>
-              <a:t>Joindre le PV de réforme ou la facture en PDF à la fiche.</a:t>
-            </a:r>
-            <a:endParaRPr lang="en-US" sz="1250" dirty="0"/>
-          </a:p>
-        </p:txBody>
-      </p:sp>
-      <p:sp>
-        <p:nvSpPr>
-          <p:cNvPr id="28" name="Shape 25"/>
-          <p:cNvSpPr/>
-          <p:nvPr/>
-        </p:nvSpPr>
-        <p:spPr>
-          <a:xfrm>
-            <a:off x="6263640" y="4224528"/>
-            <a:ext cx="566928" cy="274320"/>
-          </a:xfrm>
-          <a:prstGeom prst="roundRect">
-            <a:avLst>
-              <a:gd name="adj" fmla="val 16667"/>
-            </a:avLst>
-          </a:prstGeom>
-          <a:solidFill>
-            <a:srgbClr val="FFFDF7"/>
-          </a:solidFill>
-          <a:ln w="9525">
-            <a:solidFill>
-              <a:srgbClr val="CBC2AD"/>
-            </a:solidFill>
-            <a:prstDash val="solid"/>
-          </a:ln>
-        </p:spPr>
-      </p:sp>
-      <p:sp>
-        <p:nvSpPr>
-          <p:cNvPr id="29" name="Shape 26"/>
-          <p:cNvSpPr/>
-          <p:nvPr/>
-        </p:nvSpPr>
-        <p:spPr>
-          <a:xfrm>
-            <a:off x="6355080" y="4329684"/>
-            <a:ext cx="64008" cy="64008"/>
-          </a:xfrm>
-          <a:prstGeom prst="ellipse">
-            <a:avLst/>
-          </a:prstGeom>
-          <a:solidFill>
-            <a:srgbClr val="F3EFE6"/>
-          </a:solidFill>
-          <a:ln w="9525">
-            <a:solidFill>
-              <a:srgbClr val="CBC2AD"/>
-            </a:solidFill>
-            <a:prstDash val="solid"/>
-          </a:ln>
-        </p:spPr>
-      </p:sp>
-      <p:sp>
-        <p:nvSpPr>
-          <p:cNvPr id="30" name="Text 27"/>
-          <p:cNvSpPr txBox="1"/>
-          <p:nvPr/>
-        </p:nvSpPr>
-        <p:spPr>
-          <a:xfrm>
-            <a:off x="6483096" y="4224528"/>
-            <a:ext cx="329184" cy="274320"/>
-          </a:xfrm>
-          <a:prstGeom prst="rect">
-            <a:avLst/>
-          </a:prstGeom>
-          <a:noFill/>
-          <a:ln/>
-        </p:spPr>
-        <p:txBody>
-          <a:bodyPr wrap="none" lIns="0" tIns="0" rIns="0" bIns="0" rtlCol="0" anchor="ctr"/>
-          <a:lstStyle/>
-          <a:p>
-            <a:pPr indent="0" marL="0">
-              <a:buNone/>
-            </a:pPr>
-            <a:r>
-              <a:rPr lang="en-US" sz="1000" spc="100" kern="0" dirty="0">
-                <a:solidFill>
-                  <a:srgbClr val="17211C"/>
-                </a:solidFill>
-                <a:latin typeface="Consolas" pitchFamily="34" charset="0"/>
-                <a:ea typeface="Consolas" pitchFamily="34" charset="-122"/>
-                <a:cs typeface="Consolas" pitchFamily="34" charset="-120"/>
-              </a:rPr>
-              <a:t>03</a:t>
-            </a:r>
-            <a:endParaRPr lang="en-US" sz="1000" dirty="0"/>
-          </a:p>
-        </p:txBody>
-      </p:sp>
-      <p:sp>
-        <p:nvSpPr>
-          <p:cNvPr id="31" name="Text 28"/>
-          <p:cNvSpPr txBox="1"/>
-          <p:nvPr/>
-        </p:nvSpPr>
-        <p:spPr>
-          <a:xfrm>
-            <a:off x="7040880" y="4206240"/>
-            <a:ext cx="4602175" cy="292608"/>
-          </a:xfrm>
-          <a:prstGeom prst="rect">
-            <a:avLst/>
-          </a:prstGeom>
-          <a:noFill/>
-          <a:ln/>
-        </p:spPr>
-        <p:txBody>
-          <a:bodyPr wrap="square" lIns="0" tIns="0" rIns="0" bIns="0" rtlCol="0" anchor="t"/>
-          <a:lstStyle/>
-          <a:p>
-            <a:pPr indent="0" marL="0">
-              <a:buNone/>
-            </a:pPr>
-            <a:r>
-              <a:rPr lang="en-US" sz="1450" b="1" dirty="0">
-                <a:solidFill>
-                  <a:srgbClr val="17211C"/>
-                </a:solidFill>
-                <a:latin typeface="Calibri" pitchFamily="34" charset="0"/>
-                <a:ea typeface="Calibri" pitchFamily="34" charset="-122"/>
-                <a:cs typeface="Calibri" pitchFamily="34" charset="-120"/>
-              </a:rPr>
-              <a:t>Notifications</a:t>
-            </a:r>
-            <a:endParaRPr lang="en-US" sz="1450" dirty="0"/>
-          </a:p>
-        </p:txBody>
-      </p:sp>
-      <p:sp>
-        <p:nvSpPr>
-          <p:cNvPr id="32" name="Text 29"/>
-          <p:cNvSpPr txBox="1"/>
-          <p:nvPr/>
-        </p:nvSpPr>
-        <p:spPr>
-          <a:xfrm>
-            <a:off x="7040880" y="4517136"/>
-            <a:ext cx="4602175" cy="457200"/>
-          </a:xfrm>
-          <a:prstGeom prst="rect">
-            <a:avLst/>
-          </a:prstGeom>
-          <a:noFill/>
-          <a:ln/>
-        </p:spPr>
-        <p:txBody>
-          <a:bodyPr wrap="square" lIns="0" tIns="0" rIns="0" bIns="0" rtlCol="0" anchor="t"/>
-          <a:lstStyle/>
-          <a:p>
-            <a:pPr indent="0" marL="0">
-              <a:buNone/>
-            </a:pPr>
-            <a:r>
-              <a:rPr lang="en-US" sz="1250" dirty="0">
-                <a:solidFill>
-                  <a:srgbClr val="3F4842"/>
-                </a:solidFill>
-                <a:latin typeface="Calibri" pitchFamily="34" charset="0"/>
-                <a:ea typeface="Calibri" pitchFamily="34" charset="-122"/>
-                <a:cs typeface="Calibri" pitchFamily="34" charset="-120"/>
-              </a:rPr>
-              <a:t>Prévenir par e-mail le responsable qui doit valider un transfert.</a:t>
-            </a:r>
-            <a:endParaRPr lang="en-US" sz="1250" dirty="0"/>
-          </a:p>
-        </p:txBody>
-      </p:sp>
-      <p:sp>
-        <p:nvSpPr>
-          <p:cNvPr id="33" name="Shape 30"/>
-          <p:cNvSpPr/>
-          <p:nvPr/>
-        </p:nvSpPr>
-        <p:spPr>
-          <a:xfrm>
-            <a:off x="6263640" y="5047488"/>
-            <a:ext cx="566928" cy="274320"/>
-          </a:xfrm>
-          <a:prstGeom prst="roundRect">
-            <a:avLst>
-              <a:gd name="adj" fmla="val 16667"/>
-            </a:avLst>
-          </a:prstGeom>
-          <a:solidFill>
-            <a:srgbClr val="FFFDF7"/>
-          </a:solidFill>
-          <a:ln w="9525">
-            <a:solidFill>
-              <a:srgbClr val="CBC2AD"/>
-            </a:solidFill>
-            <a:prstDash val="solid"/>
-          </a:ln>
-        </p:spPr>
-      </p:sp>
-      <p:sp>
-        <p:nvSpPr>
-          <p:cNvPr id="34" name="Shape 31"/>
-          <p:cNvSpPr/>
-          <p:nvPr/>
-        </p:nvSpPr>
-        <p:spPr>
-          <a:xfrm>
-            <a:off x="6355080" y="5152644"/>
-            <a:ext cx="64008" cy="64008"/>
-          </a:xfrm>
-          <a:prstGeom prst="ellipse">
-            <a:avLst/>
-          </a:prstGeom>
-          <a:solidFill>
-            <a:srgbClr val="F3EFE6"/>
-          </a:solidFill>
-          <a:ln w="9525">
-            <a:solidFill>
-              <a:srgbClr val="CBC2AD"/>
-            </a:solidFill>
-            <a:prstDash val="solid"/>
-          </a:ln>
-        </p:spPr>
-      </p:sp>
-      <p:sp>
-        <p:nvSpPr>
-          <p:cNvPr id="35" name="Text 32"/>
-          <p:cNvSpPr txBox="1"/>
-          <p:nvPr/>
-        </p:nvSpPr>
-        <p:spPr>
-          <a:xfrm>
-            <a:off x="6483096" y="5047488"/>
-            <a:ext cx="329184" cy="274320"/>
-          </a:xfrm>
-          <a:prstGeom prst="rect">
-            <a:avLst/>
-          </a:prstGeom>
-          <a:noFill/>
-          <a:ln/>
-        </p:spPr>
-        <p:txBody>
-          <a:bodyPr wrap="none" lIns="0" tIns="0" rIns="0" bIns="0" rtlCol="0" anchor="ctr"/>
-          <a:lstStyle/>
-          <a:p>
-            <a:pPr indent="0" marL="0">
-              <a:buNone/>
-            </a:pPr>
-            <a:r>
-              <a:rPr lang="en-US" sz="1000" spc="100" kern="0" dirty="0">
-                <a:solidFill>
-                  <a:srgbClr val="17211C"/>
-                </a:solidFill>
-                <a:latin typeface="Consolas" pitchFamily="34" charset="0"/>
-                <a:ea typeface="Consolas" pitchFamily="34" charset="-122"/>
-                <a:cs typeface="Consolas" pitchFamily="34" charset="-120"/>
-              </a:rPr>
-              <a:t>04</a:t>
-            </a:r>
-            <a:endParaRPr lang="en-US" sz="1000" dirty="0"/>
-          </a:p>
-        </p:txBody>
-      </p:sp>
-      <p:sp>
-        <p:nvSpPr>
-          <p:cNvPr id="36" name="Text 33"/>
-          <p:cNvSpPr txBox="1"/>
-          <p:nvPr/>
-        </p:nvSpPr>
-        <p:spPr>
-          <a:xfrm>
-            <a:off x="7040880" y="5029200"/>
-            <a:ext cx="4602175" cy="292608"/>
-          </a:xfrm>
-          <a:prstGeom prst="rect">
-            <a:avLst/>
-          </a:prstGeom>
-          <a:noFill/>
-          <a:ln/>
-        </p:spPr>
-        <p:txBody>
-          <a:bodyPr wrap="square" lIns="0" tIns="0" rIns="0" bIns="0" rtlCol="0" anchor="t"/>
-          <a:lstStyle/>
-          <a:p>
-            <a:pPr indent="0" marL="0">
-              <a:buNone/>
-            </a:pPr>
-            <a:r>
-              <a:rPr lang="en-US" sz="1450" b="1" dirty="0">
-                <a:solidFill>
-                  <a:srgbClr val="17211C"/>
-                </a:solidFill>
-                <a:latin typeface="Calibri" pitchFamily="34" charset="0"/>
-                <a:ea typeface="Calibri" pitchFamily="34" charset="-122"/>
-                <a:cs typeface="Calibri" pitchFamily="34" charset="-120"/>
-              </a:rPr>
-              <a:t>Amortissement</a:t>
-            </a:r>
-            <a:endParaRPr lang="en-US" sz="1450" dirty="0"/>
-          </a:p>
-        </p:txBody>
-      </p:sp>
-      <p:sp>
-        <p:nvSpPr>
-          <p:cNvPr id="37" name="Text 34"/>
-          <p:cNvSpPr txBox="1"/>
-          <p:nvPr/>
-        </p:nvSpPr>
-        <p:spPr>
-          <a:xfrm>
-            <a:off x="7040880" y="5340096"/>
-            <a:ext cx="4602175" cy="457200"/>
-          </a:xfrm>
-          <a:prstGeom prst="rect">
-            <a:avLst/>
-          </a:prstGeom>
-          <a:noFill/>
-          <a:ln/>
-        </p:spPr>
-        <p:txBody>
-          <a:bodyPr wrap="square" lIns="0" tIns="0" rIns="0" bIns="0" rtlCol="0" anchor="t"/>
-          <a:lstStyle/>
-          <a:p>
-            <a:pPr indent="0" marL="0">
-              <a:buNone/>
-            </a:pPr>
-            <a:r>
-              <a:rPr lang="en-US" sz="1250" dirty="0">
-                <a:solidFill>
-                  <a:srgbClr val="3F4842"/>
-                </a:solidFill>
-                <a:latin typeface="Calibri" pitchFamily="34" charset="0"/>
-                <a:ea typeface="Calibri" pitchFamily="34" charset="-122"/>
-                <a:cs typeface="Calibri" pitchFamily="34" charset="-120"/>
-              </a:rPr>
-              <a:t>Valeur d'achat et durée de vie, pour le service comptable.</a:t>
-            </a:r>
-            <a:endParaRPr lang="en-US" sz="1250" dirty="0"/>
-          </a:p>
-        </p:txBody>
-      </p:sp>
-    </p:spTree>
-  </p:cSld>
-  <p:clrMapOvr>
-    <a:masterClrMapping/>
-  </p:clrMapOvr>
-</p:sld>
-</file>
-
-<file path=ppt/slides/slide18.xml><?xml version="1.0" encoding="utf-8"?>
-<p:sld xmlns:a="http://schemas.openxmlformats.org/drawingml/2006/main" xmlns:r="http://schemas.openxmlformats.org/officeDocument/2006/relationships" xmlns:p="http://schemas.openxmlformats.org/presentationml/2006/main">
-  <p:cSld name="Slide 18">
     <p:bg>
       <p:bgPr>
         <a:solidFill>
@@ -11712,7 +10272,7 @@
                 <a:ea typeface="Calibri" pitchFamily="34" charset="-122"/>
                 <a:cs typeface="Calibri" pitchFamily="34" charset="-120"/>
               </a:rPr>
-              <a:t>Adresse</a:t>
+              <a:t>Compte admin</a:t>
             </a:r>
             <a:endParaRPr lang="en-US" sz="1300" dirty="0"/>
           </a:p>
@@ -11751,7 +10311,7 @@
                 <a:ea typeface="Consolas" pitchFamily="34" charset="-122"/>
                 <a:cs typeface="Consolas" pitchFamily="34" charset="-120"/>
               </a:rPr>
-              <a:t>https://patrimo.infinityfreeapp.com</a:t>
+              <a:t>admin  /  patrimo2026</a:t>
             </a:r>
             <a:endParaRPr lang="en-US" sz="1400" dirty="0"/>
           </a:p>
@@ -11790,7 +10350,7 @@
                 <a:ea typeface="Calibri" pitchFamily="34" charset="-122"/>
                 <a:cs typeface="Calibri" pitchFamily="34" charset="-120"/>
               </a:rPr>
-              <a:t>Compte admin</a:t>
+              <a:t>Responsable DAF</a:t>
             </a:r>
             <a:endParaRPr lang="en-US" sz="1300" dirty="0"/>
           </a:p>
@@ -11829,7 +10389,7 @@
                 <a:ea typeface="Consolas" pitchFamily="34" charset="-122"/>
                 <a:cs typeface="Consolas" pitchFamily="34" charset="-120"/>
               </a:rPr>
-              <a:t>admin  /  patrimo2026</a:t>
+              <a:t>c.beibakar  /  patrimo2026</a:t>
             </a:r>
             <a:endParaRPr lang="en-US" sz="1400" dirty="0"/>
           </a:p>
@@ -11837,85 +10397,7 @@
       </p:sp>
       <p:sp>
         <p:nvSpPr>
-          <p:cNvPr id="25" name="Text 23"/>
-          <p:cNvSpPr txBox="1"/>
-          <p:nvPr/>
-        </p:nvSpPr>
-        <p:spPr>
-          <a:xfrm>
-            <a:off x="731520" y="4892040"/>
-            <a:ext cx="2011680" cy="320040"/>
-          </a:xfrm>
-          <a:prstGeom prst="rect">
-            <a:avLst/>
-          </a:prstGeom>
-          <a:noFill/>
-          <a:ln/>
-        </p:spPr>
-        <p:txBody>
-          <a:bodyPr wrap="square" lIns="0" tIns="0" rIns="0" bIns="0" rtlCol="0" anchor="t"/>
-          <a:lstStyle/>
-          <a:p>
-            <a:pPr indent="0" marL="0">
-              <a:buNone/>
-            </a:pPr>
-            <a:r>
-              <a:rPr lang="en-US" sz="1300" dirty="0">
-                <a:solidFill>
-                  <a:srgbClr val="8F998E"/>
-                </a:solidFill>
-                <a:latin typeface="Calibri" pitchFamily="34" charset="0"/>
-                <a:ea typeface="Calibri" pitchFamily="34" charset="-122"/>
-                <a:cs typeface="Calibri" pitchFamily="34" charset="-120"/>
-              </a:rPr>
-              <a:t>Responsable DAF</a:t>
-            </a:r>
-            <a:endParaRPr lang="en-US" sz="1300" dirty="0"/>
-          </a:p>
-        </p:txBody>
-      </p:sp>
-      <p:sp>
-        <p:nvSpPr>
-          <p:cNvPr id="26" name="Text 24"/>
-          <p:cNvSpPr txBox="1"/>
-          <p:nvPr/>
-        </p:nvSpPr>
-        <p:spPr>
-          <a:xfrm>
-            <a:off x="2743200" y="4892040"/>
-            <a:ext cx="5486400" cy="320040"/>
-          </a:xfrm>
-          <a:prstGeom prst="rect">
-            <a:avLst/>
-          </a:prstGeom>
-          <a:noFill/>
-          <a:ln/>
-        </p:spPr>
-        <p:txBody>
-          <a:bodyPr wrap="square" lIns="0" tIns="0" rIns="0" bIns="0" rtlCol="0" anchor="t"/>
-          <a:lstStyle/>
-          <a:p>
-            <a:pPr indent="0" marL="0">
-              <a:buNone/>
-            </a:pPr>
-            <a:r>
-              <a:rPr lang="en-US" sz="1400" dirty="0">
-                <a:solidFill>
-                  <a:srgbClr val="F1ECDD"/>
-                </a:solidFill>
-                <a:latin typeface="Consolas" pitchFamily="34" charset="0"/>
-                <a:ea typeface="Consolas" pitchFamily="34" charset="-122"/>
-                <a:cs typeface="Consolas" pitchFamily="34" charset="-120"/>
-              </a:rPr>
-              <a:t>c.beibakar  /  patrimo2026</a:t>
-            </a:r>
-            <a:endParaRPr lang="en-US" sz="1400" dirty="0"/>
-          </a:p>
-        </p:txBody>
-      </p:sp>
-      <p:sp>
-        <p:nvSpPr>
-          <p:cNvPr id="27" name="Shape 25"/>
+          <p:cNvPr id="25" name="Shape 23"/>
           <p:cNvSpPr/>
           <p:nvPr/>
         </p:nvSpPr>
@@ -11942,7 +10424,7 @@
       </p:sp>
       <p:sp>
         <p:nvSpPr>
-          <p:cNvPr id="28" name="Shape 26"/>
+          <p:cNvPr id="26" name="Shape 24"/>
           <p:cNvSpPr/>
           <p:nvPr/>
         </p:nvSpPr>
@@ -11969,7 +10451,7 @@
       </p:sp>
       <p:sp>
         <p:nvSpPr>
-          <p:cNvPr id="29" name="Text 27"/>
+          <p:cNvPr id="27" name="Text 25"/>
           <p:cNvSpPr txBox="1"/>
           <p:nvPr/>
         </p:nvSpPr>
@@ -12008,7 +10490,7 @@
       </p:sp>
       <p:sp>
         <p:nvSpPr>
-          <p:cNvPr id="31" name="Text 28"/>
+          <p:cNvPr id="29" name="Text 26"/>
           <p:cNvSpPr txBox="1"/>
           <p:nvPr/>
         </p:nvSpPr>
@@ -12039,7 +10521,7 @@
                 <a:ea typeface="Consolas" pitchFamily="34" charset="-122"/>
                 <a:cs typeface="Consolas" pitchFamily="34" charset="-120"/>
               </a:rPr>
-              <a:t>18 / 18</a:t>
+              <a:t>17 / 17</a:t>
             </a:r>
             <a:endParaRPr lang="en-US" sz="900" dirty="0"/>
           </a:p>
@@ -12240,7 +10722,7 @@
                 <a:ea typeface="Consolas" pitchFamily="34" charset="-122"/>
                 <a:cs typeface="Consolas" pitchFamily="34" charset="-120"/>
               </a:rPr>
-              <a:t>02 / 18</a:t>
+              <a:t>02 / 17</a:t>
             </a:r>
             <a:endParaRPr lang="en-US" sz="900" dirty="0"/>
           </a:p>
@@ -13695,7 +12177,7 @@
                 <a:ea typeface="Consolas" pitchFamily="34" charset="-122"/>
                 <a:cs typeface="Consolas" pitchFamily="34" charset="-120"/>
               </a:rPr>
-              <a:t>03 / 18</a:t>
+              <a:t>03 / 17</a:t>
             </a:r>
             <a:endParaRPr lang="en-US" sz="900" dirty="0"/>
           </a:p>
@@ -15419,7 +13901,7 @@
                 <a:ea typeface="Consolas" pitchFamily="34" charset="-122"/>
                 <a:cs typeface="Consolas" pitchFamily="34" charset="-120"/>
               </a:rPr>
-              <a:t>04 / 18</a:t>
+              <a:t>04 / 17</a:t>
             </a:r>
             <a:endParaRPr lang="en-US" sz="900" dirty="0"/>
           </a:p>
@@ -18185,7 +16667,7 @@
                 <a:ea typeface="Consolas" pitchFamily="34" charset="-122"/>
                 <a:cs typeface="Consolas" pitchFamily="34" charset="-120"/>
               </a:rPr>
-              <a:t>05 / 18</a:t>
+              <a:t>05 / 17</a:t>
             </a:r>
             <a:endParaRPr lang="en-US" sz="900" dirty="0"/>
           </a:p>
@@ -19287,7 +17769,7 @@
                 <a:ea typeface="Consolas" pitchFamily="34" charset="-122"/>
                 <a:cs typeface="Consolas" pitchFamily="34" charset="-120"/>
               </a:rPr>
-              <a:t>06 / 18</a:t>
+              <a:t>06 / 17</a:t>
             </a:r>
             <a:endParaRPr lang="en-US" sz="900" dirty="0"/>
           </a:p>
@@ -22528,7 +21010,7 @@
                 <a:ea typeface="Consolas" pitchFamily="34" charset="-122"/>
                 <a:cs typeface="Consolas" pitchFamily="34" charset="-120"/>
               </a:rPr>
-              <a:t>07 / 18</a:t>
+              <a:t>07 / 17</a:t>
             </a:r>
             <a:endParaRPr lang="en-US" sz="900" dirty="0"/>
           </a:p>
@@ -24352,7 +22834,7 @@
                 <a:ea typeface="Consolas" pitchFamily="34" charset="-122"/>
                 <a:cs typeface="Consolas" pitchFamily="34" charset="-120"/>
               </a:rPr>
-              <a:t>08 / 18</a:t>
+              <a:t>08 / 17</a:t>
             </a:r>
             <a:endParaRPr lang="en-US" sz="900" dirty="0"/>
           </a:p>
@@ -25470,7 +23952,7 @@
                 <a:ea typeface="Consolas" pitchFamily="34" charset="-122"/>
                 <a:cs typeface="Consolas" pitchFamily="34" charset="-120"/>
               </a:rPr>
-              <a:t>09 / 18</a:t>
+              <a:t>09 / 17</a:t>
             </a:r>
             <a:endParaRPr lang="en-US" sz="900" dirty="0"/>
           </a:p>

</xml_diff>